<commit_message>
Light-theme landing page, 7-slide HTML deck with exports, session log
- landing/index.html: light theme, scroll-driven motion, corrected pipeline copy
- landing/deck: animated HTML deck; scripts/export_deck.py builds PDF and PPTX
- docs/CLAUDE_CODE_LOG.md generated from the session transcript

Co-Authored-By: Claude Opus 5.5 <noreply@anthropic.com>
</commit_message>
<xml_diff>
--- a/docs/Capstone_Deck.pptx
+++ b/docs/Capstone_Deck.pptx
@@ -6,19 +6,14 @@
   </p:sldMasterIdLst>
   <p:sldIdLst>
     <p:sldId id="256" r:id="rId7"/>
-    <p:sldId id="257" r:id="rId8"/>
-    <p:sldId id="258" r:id="rId9"/>
-    <p:sldId id="259" r:id="rId10"/>
-    <p:sldId id="260" r:id="rId11"/>
-    <p:sldId id="261" r:id="rId12"/>
-    <p:sldId id="262" r:id="rId13"/>
-    <p:sldId id="263" r:id="rId14"/>
-    <p:sldId id="264" r:id="rId15"/>
-    <p:sldId id="265" r:id="rId16"/>
-    <p:sldId id="266" r:id="rId17"/>
-    <p:sldId id="267" r:id="rId18"/>
+    <p:sldId id="257" r:id="rId9"/>
+    <p:sldId id="258" r:id="rId10"/>
+    <p:sldId id="259" r:id="rId11"/>
+    <p:sldId id="260" r:id="rId12"/>
+    <p:sldId id="261" r:id="rId13"/>
+    <p:sldId id="262" r:id="rId14"/>
   </p:sldIdLst>
-  <p:sldSz cx="12191695" cy="6858000" type="screen4x3"/>
+  <p:sldSz cx="18288000" cy="10287000" type="screen4x3"/>
   <p:notesSz cx="6858000" cy="9144000"/>
   <p:defaultTextStyle>
     <a:defPPr>
@@ -116,6 +111,929 @@
     </a:lvl9pPr>
   </p:defaultTextStyle>
 </p:presentation>
+</file>
+
+<file path=ppt/notesMasters/notesMaster1.xml><?xml version="1.0" encoding="utf-8"?>
+<p:notesMaster xmlns:a="http://schemas.openxmlformats.org/drawingml/2006/main" xmlns:p="http://schemas.openxmlformats.org/presentationml/2006/main" xmlns:r="http://schemas.openxmlformats.org/officeDocument/2006/relationships">
+  <p:cSld>
+    <p:bg>
+      <p:bgRef idx="1001">
+        <a:schemeClr val="bg1"/>
+      </p:bgRef>
+    </p:bg>
+    <p:spTree>
+      <p:nvGrpSpPr>
+        <p:cNvPr id="1" name=""/>
+        <p:cNvGrpSpPr/>
+        <p:nvPr/>
+      </p:nvGrpSpPr>
+      <p:grpSpPr>
+        <a:xfrm>
+          <a:off x="0" y="0"/>
+          <a:ext cx="0" cy="0"/>
+          <a:chOff x="0" y="0"/>
+          <a:chExt cx="0" cy="0"/>
+        </a:xfrm>
+      </p:grpSpPr>
+      <p:sp>
+        <p:nvSpPr>
+          <p:cNvPr id="2" name="Header Placeholder 1"/>
+          <p:cNvSpPr>
+            <a:spLocks noGrp="1"/>
+          </p:cNvSpPr>
+          <p:nvPr>
+            <p:ph type="hdr" sz="quarter"/>
+          </p:nvPr>
+        </p:nvSpPr>
+        <p:spPr>
+          <a:xfrm>
+            <a:off x="0" y="0"/>
+            <a:ext cx="2971800" cy="457200"/>
+          </a:xfrm>
+          <a:prstGeom prst="rect">
+            <a:avLst/>
+          </a:prstGeom>
+        </p:spPr>
+        <p:txBody>
+          <a:bodyPr vert="horz" lIns="91440" tIns="45720" rIns="91440" bIns="45720" rtlCol="0"/>
+          <a:lstStyle>
+            <a:lvl1pPr algn="l">
+              <a:defRPr sz="1200"/>
+            </a:lvl1pPr>
+          </a:lstStyle>
+          <a:p>
+            <a:endParaRPr lang="en-US"/>
+          </a:p>
+        </p:txBody>
+      </p:sp>
+      <p:sp>
+        <p:nvSpPr>
+          <p:cNvPr id="3" name="Date Placeholder 2"/>
+          <p:cNvSpPr>
+            <a:spLocks noGrp="1"/>
+          </p:cNvSpPr>
+          <p:nvPr>
+            <p:ph type="dt" idx="1"/>
+          </p:nvPr>
+        </p:nvSpPr>
+        <p:spPr>
+          <a:xfrm>
+            <a:off x="3884613" y="0"/>
+            <a:ext cx="2971800" cy="457200"/>
+          </a:xfrm>
+          <a:prstGeom prst="rect">
+            <a:avLst/>
+          </a:prstGeom>
+        </p:spPr>
+        <p:txBody>
+          <a:bodyPr vert="horz" lIns="91440" tIns="45720" rIns="91440" bIns="45720" rtlCol="0"/>
+          <a:lstStyle>
+            <a:lvl1pPr algn="r">
+              <a:defRPr sz="1200"/>
+            </a:lvl1pPr>
+          </a:lstStyle>
+          <a:p>
+            <a:fld id="{0F89C1C7-3DCD-1040-A9CF-14679D8B5DDD}" type="datetimeFigureOut">
+              <a:rPr lang="en-US" smtClean="0"/>
+              <a:t>10/17/16</a:t>
+            </a:fld>
+            <a:endParaRPr lang="en-US"/>
+          </a:p>
+        </p:txBody>
+      </p:sp>
+      <p:sp>
+        <p:nvSpPr>
+          <p:cNvPr id="4" name="Slide Image Placeholder 3"/>
+          <p:cNvSpPr>
+            <a:spLocks noGrp="1" noRot="1" noChangeAspect="1"/>
+          </p:cNvSpPr>
+          <p:nvPr>
+            <p:ph type="sldImg" idx="2"/>
+          </p:nvPr>
+        </p:nvSpPr>
+        <p:spPr>
+          <a:xfrm>
+            <a:off x="1143000" y="685800"/>
+            <a:ext cx="4572000" cy="3429000"/>
+          </a:xfrm>
+          <a:prstGeom prst="rect">
+            <a:avLst/>
+          </a:prstGeom>
+          <a:noFill/>
+          <a:ln w="12700">
+            <a:solidFill>
+              <a:prstClr val="black"/>
+            </a:solidFill>
+          </a:ln>
+        </p:spPr>
+        <p:txBody>
+          <a:bodyPr vert="horz" lIns="91440" tIns="45720" rIns="91440" bIns="45720" rtlCol="0" anchor="ctr"/>
+          <a:lstStyle/>
+          <a:p>
+            <a:endParaRPr lang="en-US"/>
+          </a:p>
+        </p:txBody>
+      </p:sp>
+      <p:sp>
+        <p:nvSpPr>
+          <p:cNvPr id="5" name="Notes Placeholder 4"/>
+          <p:cNvSpPr>
+            <a:spLocks noGrp="1"/>
+          </p:cNvSpPr>
+          <p:nvPr>
+            <p:ph type="body" sz="quarter" idx="3"/>
+          </p:nvPr>
+        </p:nvSpPr>
+        <p:spPr>
+          <a:xfrm>
+            <a:off x="685800" y="4343400"/>
+            <a:ext cx="5486400" cy="4114800"/>
+          </a:xfrm>
+          <a:prstGeom prst="rect">
+            <a:avLst/>
+          </a:prstGeom>
+        </p:spPr>
+        <p:txBody>
+          <a:bodyPr vert="horz" lIns="91440" tIns="45720" rIns="91440" bIns="45720" rtlCol="0"/>
+          <a:lstStyle/>
+          <a:p>
+            <a:pPr lvl="0"/>
+            <a:r>
+              <a:rPr lang="en-US" smtClean="0"/>
+              <a:t>Click to edit Master text styles</a:t>
+            </a:r>
+          </a:p>
+          <a:p>
+            <a:pPr lvl="1"/>
+            <a:r>
+              <a:rPr lang="en-US" smtClean="0"/>
+              <a:t>Second level</a:t>
+            </a:r>
+          </a:p>
+          <a:p>
+            <a:pPr lvl="2"/>
+            <a:r>
+              <a:rPr lang="en-US" smtClean="0"/>
+              <a:t>Third level</a:t>
+            </a:r>
+          </a:p>
+          <a:p>
+            <a:pPr lvl="3"/>
+            <a:r>
+              <a:rPr lang="en-US" smtClean="0"/>
+              <a:t>Fourth level</a:t>
+            </a:r>
+          </a:p>
+          <a:p>
+            <a:pPr lvl="4"/>
+            <a:r>
+              <a:rPr lang="en-US" smtClean="0"/>
+              <a:t>Fifth level</a:t>
+            </a:r>
+            <a:endParaRPr lang="en-US"/>
+          </a:p>
+        </p:txBody>
+      </p:sp>
+      <p:sp>
+        <p:nvSpPr>
+          <p:cNvPr id="6" name="Footer Placeholder 5"/>
+          <p:cNvSpPr>
+            <a:spLocks noGrp="1"/>
+          </p:cNvSpPr>
+          <p:nvPr>
+            <p:ph type="ftr" sz="quarter" idx="4"/>
+          </p:nvPr>
+        </p:nvSpPr>
+        <p:spPr>
+          <a:xfrm>
+            <a:off x="0" y="8685213"/>
+            <a:ext cx="2971800" cy="457200"/>
+          </a:xfrm>
+          <a:prstGeom prst="rect">
+            <a:avLst/>
+          </a:prstGeom>
+        </p:spPr>
+        <p:txBody>
+          <a:bodyPr vert="horz" lIns="91440" tIns="45720" rIns="91440" bIns="45720" rtlCol="0" anchor="b"/>
+          <a:lstStyle>
+            <a:lvl1pPr algn="l">
+              <a:defRPr sz="1200"/>
+            </a:lvl1pPr>
+          </a:lstStyle>
+          <a:p>
+            <a:endParaRPr lang="en-US"/>
+          </a:p>
+        </p:txBody>
+      </p:sp>
+      <p:sp>
+        <p:nvSpPr>
+          <p:cNvPr id="7" name="Slide Number Placeholder 6"/>
+          <p:cNvSpPr>
+            <a:spLocks noGrp="1"/>
+          </p:cNvSpPr>
+          <p:nvPr>
+            <p:ph type="sldNum" sz="quarter" idx="5"/>
+          </p:nvPr>
+        </p:nvSpPr>
+        <p:spPr>
+          <a:xfrm>
+            <a:off x="3884613" y="8685213"/>
+            <a:ext cx="2971800" cy="457200"/>
+          </a:xfrm>
+          <a:prstGeom prst="rect">
+            <a:avLst/>
+          </a:prstGeom>
+        </p:spPr>
+        <p:txBody>
+          <a:bodyPr vert="horz" lIns="91440" tIns="45720" rIns="91440" bIns="45720" rtlCol="0" anchor="b"/>
+          <a:lstStyle>
+            <a:lvl1pPr algn="r">
+              <a:defRPr sz="1200"/>
+            </a:lvl1pPr>
+          </a:lstStyle>
+          <a:p>
+            <a:fld id="{BB5E49A5-4136-284D-997B-48E1D791AD67}" type="slidenum">
+              <a:rPr lang="en-US" smtClean="0"/>
+              <a:t>‹#›</a:t>
+            </a:fld>
+            <a:endParaRPr lang="en-US"/>
+          </a:p>
+        </p:txBody>
+      </p:sp>
+    </p:spTree>
+    <p:extLst>
+      <p:ext uri="{BB962C8B-B14F-4D97-AF65-F5344CB8AC3E}">
+        <p14:creationId xmlns:p14="http://schemas.microsoft.com/office/powerpoint/2010/main" val="2623252185"/>
+      </p:ext>
+    </p:extLst>
+  </p:cSld>
+  <p:clrMap bg1="lt1" tx1="dk1" bg2="lt2" tx2="dk2" accent1="accent1" accent2="accent2" accent3="accent3" accent4="accent4" accent5="accent5" accent6="accent6" hlink="hlink" folHlink="folHlink"/>
+  <p:notesStyle>
+    <a:lvl1pPr marL="0" algn="l" defTabSz="457200" rtl="0" eaLnBrk="1" latinLnBrk="0" hangingPunct="1">
+      <a:defRPr sz="1200" kern="1200">
+        <a:solidFill>
+          <a:schemeClr val="tx1"/>
+        </a:solidFill>
+        <a:latin typeface="+mn-lt"/>
+        <a:ea typeface="+mn-ea"/>
+        <a:cs typeface="+mn-cs"/>
+      </a:defRPr>
+    </a:lvl1pPr>
+    <a:lvl2pPr marL="457200" algn="l" defTabSz="457200" rtl="0" eaLnBrk="1" latinLnBrk="0" hangingPunct="1">
+      <a:defRPr sz="1200" kern="1200">
+        <a:solidFill>
+          <a:schemeClr val="tx1"/>
+        </a:solidFill>
+        <a:latin typeface="+mn-lt"/>
+        <a:ea typeface="+mn-ea"/>
+        <a:cs typeface="+mn-cs"/>
+      </a:defRPr>
+    </a:lvl2pPr>
+    <a:lvl3pPr marL="914400" algn="l" defTabSz="457200" rtl="0" eaLnBrk="1" latinLnBrk="0" hangingPunct="1">
+      <a:defRPr sz="1200" kern="1200">
+        <a:solidFill>
+          <a:schemeClr val="tx1"/>
+        </a:solidFill>
+        <a:latin typeface="+mn-lt"/>
+        <a:ea typeface="+mn-ea"/>
+        <a:cs typeface="+mn-cs"/>
+      </a:defRPr>
+    </a:lvl3pPr>
+    <a:lvl4pPr marL="1371600" algn="l" defTabSz="457200" rtl="0" eaLnBrk="1" latinLnBrk="0" hangingPunct="1">
+      <a:defRPr sz="1200" kern="1200">
+        <a:solidFill>
+          <a:schemeClr val="tx1"/>
+        </a:solidFill>
+        <a:latin typeface="+mn-lt"/>
+        <a:ea typeface="+mn-ea"/>
+        <a:cs typeface="+mn-cs"/>
+      </a:defRPr>
+    </a:lvl4pPr>
+    <a:lvl5pPr marL="1828800" algn="l" defTabSz="457200" rtl="0" eaLnBrk="1" latinLnBrk="0" hangingPunct="1">
+      <a:defRPr sz="1200" kern="1200">
+        <a:solidFill>
+          <a:schemeClr val="tx1"/>
+        </a:solidFill>
+        <a:latin typeface="+mn-lt"/>
+        <a:ea typeface="+mn-ea"/>
+        <a:cs typeface="+mn-cs"/>
+      </a:defRPr>
+    </a:lvl5pPr>
+    <a:lvl6pPr marL="2286000" algn="l" defTabSz="457200" rtl="0" eaLnBrk="1" latinLnBrk="0" hangingPunct="1">
+      <a:defRPr sz="1200" kern="1200">
+        <a:solidFill>
+          <a:schemeClr val="tx1"/>
+        </a:solidFill>
+        <a:latin typeface="+mn-lt"/>
+        <a:ea typeface="+mn-ea"/>
+        <a:cs typeface="+mn-cs"/>
+      </a:defRPr>
+    </a:lvl6pPr>
+    <a:lvl7pPr marL="2743200" algn="l" defTabSz="457200" rtl="0" eaLnBrk="1" latinLnBrk="0" hangingPunct="1">
+      <a:defRPr sz="1200" kern="1200">
+        <a:solidFill>
+          <a:schemeClr val="tx1"/>
+        </a:solidFill>
+        <a:latin typeface="+mn-lt"/>
+        <a:ea typeface="+mn-ea"/>
+        <a:cs typeface="+mn-cs"/>
+      </a:defRPr>
+    </a:lvl7pPr>
+    <a:lvl8pPr marL="3200400" algn="l" defTabSz="457200" rtl="0" eaLnBrk="1" latinLnBrk="0" hangingPunct="1">
+      <a:defRPr sz="1200" kern="1200">
+        <a:solidFill>
+          <a:schemeClr val="tx1"/>
+        </a:solidFill>
+        <a:latin typeface="+mn-lt"/>
+        <a:ea typeface="+mn-ea"/>
+        <a:cs typeface="+mn-cs"/>
+      </a:defRPr>
+    </a:lvl8pPr>
+    <a:lvl9pPr marL="3657600" algn="l" defTabSz="457200" rtl="0" eaLnBrk="1" latinLnBrk="0" hangingPunct="1">
+      <a:defRPr sz="1200" kern="1200">
+        <a:solidFill>
+          <a:schemeClr val="tx1"/>
+        </a:solidFill>
+        <a:latin typeface="+mn-lt"/>
+        <a:ea typeface="+mn-ea"/>
+        <a:cs typeface="+mn-cs"/>
+      </a:defRPr>
+    </a:lvl9pPr>
+  </p:notesStyle>
+</p:notesMaster>
+</file>
+
+<file path=ppt/notesSlides/notesSlide1.xml><?xml version="1.0" encoding="utf-8"?>
+<p:notes xmlns:a="http://schemas.openxmlformats.org/drawingml/2006/main" xmlns:p="http://schemas.openxmlformats.org/presentationml/2006/main" xmlns:r="http://schemas.openxmlformats.org/officeDocument/2006/relationships">
+  <p:cSld>
+    <p:spTree>
+      <p:nvGrpSpPr>
+        <p:cNvPr id="1" name=""/>
+        <p:cNvGrpSpPr/>
+        <p:nvPr/>
+      </p:nvGrpSpPr>
+      <p:grpSpPr>
+        <a:xfrm>
+          <a:off x="0" y="0"/>
+          <a:ext cx="0" cy="0"/>
+          <a:chOff x="0" y="0"/>
+          <a:chExt cx="0" cy="0"/>
+        </a:xfrm>
+      </p:grpSpPr>
+      <p:sp>
+        <p:nvSpPr>
+          <p:cNvPr id="2" name="Slide Image Placeholder 1"/>
+          <p:cNvSpPr>
+            <a:spLocks noGrp="1"/>
+          </p:cNvSpPr>
+          <p:nvPr>
+            <p:ph type="sldImg" idx="2"/>
+          </p:nvPr>
+        </p:nvSpPr>
+        <p:spPr/>
+      </p:sp>
+      <p:sp>
+        <p:nvSpPr>
+          <p:cNvPr id="3" name="Notes Placeholder 2"/>
+          <p:cNvSpPr>
+            <a:spLocks noGrp="1"/>
+          </p:cNvSpPr>
+          <p:nvPr>
+            <p:ph type="body" idx="3" sz="quarter"/>
+          </p:nvPr>
+        </p:nvSpPr>
+        <p:spPr/>
+        <p:txBody>
+          <a:bodyPr/>
+          <a:lstStyle/>
+          <a:p>
+            <a:r>
+              <a:t>A forecast is a range.</a:t>
+            </a:r>
+          </a:p>
+          <a:p>
+            <a:r>
+              <a:t>Section: Executive pitch</a:t>
+            </a:r>
+          </a:p>
+          <a:p/>
+          <a:p>
+            <a:r>
+              <a:t>AI Portfolio Advisor: profile-aware NSE stock recommendations with a pessimistic, median and optimistic (P10, P50, P90) 21-trading-day forecast from three LightGBM quantile models, for 60 NSE stocks. Agenda: 5-minute executive pitch, 10-minute technical deep dive, live demo. Group 5: B Gokul Vaigundh (DBM/1015/03), Balaji G (DBM/1016/03), Shashaanth NC (DBM/1070/03).</a:t>
+            </a:r>
+          </a:p>
+        </p:txBody>
+      </p:sp>
+      <p:sp>
+        <p:nvSpPr>
+          <p:cNvPr id="4" name="Slide Number Placeholder 3"/>
+          <p:cNvSpPr>
+            <a:spLocks noGrp="1"/>
+          </p:cNvSpPr>
+          <p:nvPr>
+            <p:ph type="sldNum" idx="5" sz="quarter"/>
+          </p:nvPr>
+        </p:nvSpPr>
+        <p:spPr/>
+      </p:sp>
+    </p:spTree>
+  </p:cSld>
+  <p:clrMapOvr>
+    <a:masterClrMapping/>
+  </p:clrMapOvr>
+</p:notes>
+</file>
+
+<file path=ppt/notesSlides/notesSlide2.xml><?xml version="1.0" encoding="utf-8"?>
+<p:notes xmlns:a="http://schemas.openxmlformats.org/drawingml/2006/main" xmlns:p="http://schemas.openxmlformats.org/presentationml/2006/main" xmlns:r="http://schemas.openxmlformats.org/officeDocument/2006/relationships">
+  <p:cSld>
+    <p:spTree>
+      <p:nvGrpSpPr>
+        <p:cNvPr id="1" name=""/>
+        <p:cNvGrpSpPr/>
+        <p:nvPr/>
+      </p:nvGrpSpPr>
+      <p:grpSpPr>
+        <a:xfrm>
+          <a:off x="0" y="0"/>
+          <a:ext cx="0" cy="0"/>
+          <a:chOff x="0" y="0"/>
+          <a:chExt cx="0" cy="0"/>
+        </a:xfrm>
+      </p:grpSpPr>
+      <p:sp>
+        <p:nvSpPr>
+          <p:cNvPr id="2" name="Slide Image Placeholder 1"/>
+          <p:cNvSpPr>
+            <a:spLocks noGrp="1"/>
+          </p:cNvSpPr>
+          <p:nvPr>
+            <p:ph type="sldImg" idx="2"/>
+          </p:nvPr>
+        </p:nvSpPr>
+        <p:spPr/>
+      </p:sp>
+      <p:sp>
+        <p:nvSpPr>
+          <p:cNvPr id="3" name="Notes Placeholder 2"/>
+          <p:cNvSpPr>
+            <a:spLocks noGrp="1"/>
+          </p:cNvSpPr>
+          <p:nvPr>
+            <p:ph type="body" idx="3" sz="quarter"/>
+          </p:nvPr>
+        </p:nvSpPr>
+        <p:spPr/>
+        <p:txBody>
+          <a:bodyPr/>
+          <a:lstStyle/>
+          <a:p>
+            <a:r>
+              <a:t>Advisers get a tip. They need the range, the reason and the size.</a:t>
+            </a:r>
+          </a:p>
+          <a:p>
+            <a:r>
+              <a:t>Section: Executive pitch</a:t>
+            </a:r>
+          </a:p>
+          <a:p/>
+          <a:p>
+            <a:r>
+              <a:t>Target user: an independent wealth adviser or self-directed investor in India who reviews a portfolio monthly. Today picks come from tips and single-number targets with no view of the range of outcomes or fit with risk tolerance. The product takes a risk profile and capital, blends four evidence pillars (technical score, fundamental score, model forecast, risk fit) by profile weights, and returns a ranked book marked STRONG BUY / BUY / WATCH / PASS with a P10/P50/P90 21-day return, a position size from Hierarchical Risk Parity and SHAP drivers per stock.</a:t>
+            </a:r>
+          </a:p>
+        </p:txBody>
+      </p:sp>
+      <p:sp>
+        <p:nvSpPr>
+          <p:cNvPr id="4" name="Slide Number Placeholder 3"/>
+          <p:cNvSpPr>
+            <a:spLocks noGrp="1"/>
+          </p:cNvSpPr>
+          <p:nvPr>
+            <p:ph type="sldNum" idx="5" sz="quarter"/>
+          </p:nvPr>
+        </p:nvSpPr>
+        <p:spPr/>
+      </p:sp>
+    </p:spTree>
+  </p:cSld>
+  <p:clrMapOvr>
+    <a:masterClrMapping/>
+  </p:clrMapOvr>
+</p:notes>
+</file>
+
+<file path=ppt/notesSlides/notesSlide3.xml><?xml version="1.0" encoding="utf-8"?>
+<p:notes xmlns:a="http://schemas.openxmlformats.org/drawingml/2006/main" xmlns:p="http://schemas.openxmlformats.org/presentationml/2006/main" xmlns:r="http://schemas.openxmlformats.org/officeDocument/2006/relationships">
+  <p:cSld>
+    <p:spTree>
+      <p:nvGrpSpPr>
+        <p:cNvPr id="1" name=""/>
+        <p:cNvGrpSpPr/>
+        <p:nvPr/>
+      </p:nvGrpSpPr>
+      <p:grpSpPr>
+        <a:xfrm>
+          <a:off x="0" y="0"/>
+          <a:ext cx="0" cy="0"/>
+          <a:chOff x="0" y="0"/>
+          <a:chExt cx="0" cy="0"/>
+        </a:xfrm>
+      </p:grpSpPr>
+      <p:sp>
+        <p:nvSpPr>
+          <p:cNvPr id="2" name="Slide Image Placeholder 1"/>
+          <p:cNvSpPr>
+            <a:spLocks noGrp="1"/>
+          </p:cNvSpPr>
+          <p:nvPr>
+            <p:ph type="sldImg" idx="2"/>
+          </p:nvPr>
+        </p:nvSpPr>
+        <p:spPr/>
+      </p:sp>
+      <p:sp>
+        <p:nvSpPr>
+          <p:cNvPr id="3" name="Notes Placeholder 2"/>
+          <p:cNvSpPr>
+            <a:spLocks noGrp="1"/>
+          </p:cNvSpPr>
+          <p:nvPr>
+            <p:ph type="body" idx="3" sz="quarter"/>
+          </p:nvPr>
+        </p:nvSpPr>
+        <p:spPr/>
+        <p:txBody>
+          <a:bodyPr/>
+          <a:lstStyle/>
+          <a:p>
+            <a:r>
+              <a:t>467 adviser hours back each year: a 483% return on cost.</a:t>
+            </a:r>
+          </a:p>
+          <a:p>
+            <a:r>
+              <a:t>Section: Executive pitch</a:t>
+            </a:r>
+          </a:p>
+          <a:p/>
+          <a:p>
+            <a:r>
+              <a:t>ROI is an adviser time-saving case built on stated assumptions: 200 clients x 4 reviews a year = 800 reviews; screening time cut from 45 to 10 minutes saves 35 minutes each = 467 hours a year; at Rs 1,500 per adviser hour that is Rs 7.0 lakh (Rs 700,000); against an assumed running cost of Rs 1.2 lakh a year the return on cost is 483%. Market strategy: free research tool for self-directed investors; paid seat for advisers who need client-ready evidence sheets; brokers as a channel through the existing Upstox / Zerodha live-quote adapters. Not claimed: extra return. Hold-out top-5 strategy returned -4.4% a year against +3.3% for holding all stocks equally.</a:t>
+            </a:r>
+          </a:p>
+        </p:txBody>
+      </p:sp>
+      <p:sp>
+        <p:nvSpPr>
+          <p:cNvPr id="4" name="Slide Number Placeholder 3"/>
+          <p:cNvSpPr>
+            <a:spLocks noGrp="1"/>
+          </p:cNvSpPr>
+          <p:nvPr>
+            <p:ph type="sldNum" idx="5" sz="quarter"/>
+          </p:nvPr>
+        </p:nvSpPr>
+        <p:spPr/>
+      </p:sp>
+    </p:spTree>
+  </p:cSld>
+  <p:clrMapOvr>
+    <a:masterClrMapping/>
+  </p:clrMapOvr>
+</p:notes>
+</file>
+
+<file path=ppt/notesSlides/notesSlide4.xml><?xml version="1.0" encoding="utf-8"?>
+<p:notes xmlns:a="http://schemas.openxmlformats.org/drawingml/2006/main" xmlns:p="http://schemas.openxmlformats.org/presentationml/2006/main" xmlns:r="http://schemas.openxmlformats.org/officeDocument/2006/relationships">
+  <p:cSld>
+    <p:spTree>
+      <p:nvGrpSpPr>
+        <p:cNvPr id="1" name=""/>
+        <p:cNvGrpSpPr/>
+        <p:nvPr/>
+      </p:nvGrpSpPr>
+      <p:grpSpPr>
+        <a:xfrm>
+          <a:off x="0" y="0"/>
+          <a:ext cx="0" cy="0"/>
+          <a:chOff x="0" y="0"/>
+          <a:chExt cx="0" cy="0"/>
+        </a:xfrm>
+      </p:grpSpPr>
+      <p:sp>
+        <p:nvSpPr>
+          <p:cNvPr id="2" name="Slide Image Placeholder 1"/>
+          <p:cNvSpPr>
+            <a:spLocks noGrp="1"/>
+          </p:cNvSpPr>
+          <p:nvPr>
+            <p:ph type="sldImg" idx="2"/>
+          </p:nvPr>
+        </p:nvSpPr>
+        <p:spPr/>
+      </p:sp>
+      <p:sp>
+        <p:nvSpPr>
+          <p:cNvPr id="3" name="Notes Placeholder 2"/>
+          <p:cNvSpPr>
+            <a:spLocks noGrp="1"/>
+          </p:cNvSpPr>
+          <p:nvPr>
+            <p:ph type="body" idx="3" sz="quarter"/>
+          </p:nvPr>
+        </p:nvSpPr>
+        <p:spPr/>
+        <p:txBody>
+          <a:bodyPr/>
+          <a:lstStyle/>
+          <a:p>
+            <a:r>
+              <a:t>From raw prices to the app, with leakage designed out.</a:t>
+            </a:r>
+          </a:p>
+          <a:p>
+            <a:r>
+              <a:t>Section: Technical deep dive</a:t>
+            </a:r>
+          </a:p>
+          <a:p/>
+          <a:p>
+            <a:r>
+              <a:t>Architecture: prices -&gt; features -&gt; selection -&gt; purged walk-forward CV -&gt; quantile models -&gt; artifact -&gt; app. src/data.py downloads Yahoo Finance prices, builds 19 candidate features, selects features and defines the splits. src/model.py tunes, cross-validates, trains three LightGBM quantile models, evaluates the hold-out, computes SHAP, backtests and exports data/artifacts.pkl and reports/metrics.json. app.py is the Streamlit interface; src/portfolio_advisor/core.py is the decision engine. Data: 60 liquid NSE large caps, five per sector across 12 sectors, daily adjusted prices 2018-02-19 to 2026-10-08, 118,641 stock-days; label = return over the next 21 trading days. Feature selection: greedy mutual-information relevance minus 0.5 x redundancy on development data only; kept 10 of 19: mkt_vol_21, fracdiff_close, rel_ret_21, volume_surge, mom_126_21, Stoch_K, vol_63, ret_63, OBV_delta, Boll_BW. Company fundamentals were removed from the model because only today's ratios exist, so using them on past dates would leak future information.</a:t>
+            </a:r>
+          </a:p>
+        </p:txBody>
+      </p:sp>
+      <p:sp>
+        <p:nvSpPr>
+          <p:cNvPr id="4" name="Slide Number Placeholder 3"/>
+          <p:cNvSpPr>
+            <a:spLocks noGrp="1"/>
+          </p:cNvSpPr>
+          <p:nvPr>
+            <p:ph type="sldNum" idx="5" sz="quarter"/>
+          </p:nvPr>
+        </p:nvSpPr>
+        <p:spPr/>
+      </p:sp>
+    </p:spTree>
+  </p:cSld>
+  <p:clrMapOvr>
+    <a:masterClrMapping/>
+  </p:clrMapOvr>
+</p:notes>
+</file>
+
+<file path=ppt/notesSlides/notesSlide5.xml><?xml version="1.0" encoding="utf-8"?>
+<p:notes xmlns:a="http://schemas.openxmlformats.org/drawingml/2006/main" xmlns:p="http://schemas.openxmlformats.org/presentationml/2006/main" xmlns:r="http://schemas.openxmlformats.org/officeDocument/2006/relationships">
+  <p:cSld>
+    <p:spTree>
+      <p:nvGrpSpPr>
+        <p:cNvPr id="1" name=""/>
+        <p:cNvGrpSpPr/>
+        <p:nvPr/>
+      </p:nvGrpSpPr>
+      <p:grpSpPr>
+        <a:xfrm>
+          <a:off x="0" y="0"/>
+          <a:ext cx="0" cy="0"/>
+          <a:chOff x="0" y="0"/>
+          <a:chExt cx="0" cy="0"/>
+        </a:xfrm>
+      </p:grpSpPr>
+      <p:sp>
+        <p:nvSpPr>
+          <p:cNvPr id="2" name="Slide Image Placeholder 1"/>
+          <p:cNvSpPr>
+            <a:spLocks noGrp="1"/>
+          </p:cNvSpPr>
+          <p:nvPr>
+            <p:ph type="sldImg" idx="2"/>
+          </p:nvPr>
+        </p:nvSpPr>
+        <p:spPr/>
+      </p:sp>
+      <p:sp>
+        <p:nvSpPr>
+          <p:cNvPr id="3" name="Notes Placeholder 2"/>
+          <p:cNvSpPr>
+            <a:spLocks noGrp="1"/>
+          </p:cNvSpPr>
+          <p:nvPr>
+            <p:ph type="body" idx="3" sz="quarter"/>
+          </p:nvPr>
+        </p:nvSpPr>
+        <p:spPr/>
+        <p:txBody>
+          <a:bodyPr/>
+          <a:lstStyle/>
+          <a:p>
+            <a:r>
+              <a:t>Tuning beat the notebook by 9.2%, and only tied the naive baseline.</a:t>
+            </a:r>
+          </a:p>
+          <a:p>
+            <a:r>
+              <a:t>Section: Technical deep dive</a:t>
+            </a:r>
+          </a:p>
+          <a:p/>
+          <a:p>
+            <a:r>
+              <a:t>Validation: purged walk-forward cross-validation, 5 expanding folds. Each fold trains on the past and validates on the next block, with 31 trading days removed in between because each label looks 21 days ahead. Hold-out 2025-01-23 to 2026-09-09 (24,413 stock-days) never used for selection or tuning. Search: random search over 25 settings x 5 folds x 3 quantiles = 375 model fits, scored by mean pinball loss. CV pinball loss: naive baseline 0.02395; LightGBM notebook settings 0.02648; LightGBM tuned 0.02406 +/- 0.00529; Ridge is a point forecast with no quantiles (CV MAE 0.0731 vs naive 0.0722). Tuning improved on the notebook settings by 9.2%. Against the naive no-feature baseline the tuned model is 0.5% worse, inside fold-to-fold variation. Chosen settings: n_estimators=100, learning_rate=0.02, num_leaves=4, min_child_samples=50, subsample=0.8, colsample_bytree=0.5, reg_lambda=0. With a weak signal, complex trees fit noise.</a:t>
+            </a:r>
+          </a:p>
+        </p:txBody>
+      </p:sp>
+      <p:sp>
+        <p:nvSpPr>
+          <p:cNvPr id="4" name="Slide Number Placeholder 3"/>
+          <p:cNvSpPr>
+            <a:spLocks noGrp="1"/>
+          </p:cNvSpPr>
+          <p:nvPr>
+            <p:ph type="sldNum" idx="5" sz="quarter"/>
+          </p:nvPr>
+        </p:nvSpPr>
+        <p:spPr/>
+      </p:sp>
+    </p:spTree>
+  </p:cSld>
+  <p:clrMapOvr>
+    <a:masterClrMapping/>
+  </p:clrMapOvr>
+</p:notes>
+</file>
+
+<file path=ppt/notesSlides/notesSlide6.xml><?xml version="1.0" encoding="utf-8"?>
+<p:notes xmlns:a="http://schemas.openxmlformats.org/drawingml/2006/main" xmlns:p="http://schemas.openxmlformats.org/presentationml/2006/main" xmlns:r="http://schemas.openxmlformats.org/officeDocument/2006/relationships">
+  <p:cSld>
+    <p:spTree>
+      <p:nvGrpSpPr>
+        <p:cNvPr id="1" name=""/>
+        <p:cNvGrpSpPr/>
+        <p:nvPr/>
+      </p:nvGrpSpPr>
+      <p:grpSpPr>
+        <a:xfrm>
+          <a:off x="0" y="0"/>
+          <a:ext cx="0" cy="0"/>
+          <a:chOff x="0" y="0"/>
+          <a:chExt cx="0" cy="0"/>
+        </a:xfrm>
+      </p:grpSpPr>
+      <p:sp>
+        <p:nvSpPr>
+          <p:cNvPr id="2" name="Slide Image Placeholder 1"/>
+          <p:cNvSpPr>
+            <a:spLocks noGrp="1"/>
+          </p:cNvSpPr>
+          <p:nvPr>
+            <p:ph type="sldImg" idx="2"/>
+          </p:nvPr>
+        </p:nvSpPr>
+        <p:spPr/>
+      </p:sp>
+      <p:sp>
+        <p:nvSpPr>
+          <p:cNvPr id="3" name="Notes Placeholder 2"/>
+          <p:cNvSpPr>
+            <a:spLocks noGrp="1"/>
+          </p:cNvSpPr>
+          <p:nvPr>
+            <p:ph type="body" idx="3" sz="quarter"/>
+          </p:nvPr>
+        </p:nvSpPr>
+        <p:spPr/>
+        <p:txBody>
+          <a:bodyPr/>
+          <a:lstStyle/>
+          <a:p>
+            <a:r>
+              <a:t>Honest ranges. No market-beating picks.</a:t>
+            </a:r>
+          </a:p>
+          <a:p>
+            <a:r>
+              <a:t>Section: Technical deep dive</a:t>
+            </a:r>
+          </a:p>
+          <a:p/>
+          <a:p>
+            <a:r>
+              <a:t>Hold-out period 2025-01-23 to 2026-09-09, 24,413 stock-days never used for selection or tuning. P10-P90 coverage 82.4% against an 80% target. Pinball loss: LightGBM 0.01880 vs naive 0.01915. Rank information coefficient +0.046, positive on 56% of 407 days. Direction right 51.0% of the time. Backtest on the hold-out (every 21 trading days hold the 5 highest median forecasts, equal weight, 20 bps cost; benchmark = all stocks equal weight): strategy -4.4% a year vs benchmark +3.3% a year, median over 21 start days; excess -6.4% (range -16.8% to +7.1%); beat the benchmark from 24% of start days. In cross-validation folds the excess was +1.6% a year (range -4.3% to +16.6%). SHAP (TreeExplainer on the median model), largest drivers: mkt_vol_21, mom_126_21, fracdiff_close, vol_63, ret_63. Error analysis: calm markets rank IC -0.079, normal +0.076, turbulent +0.142; direction right 31.1% when the market fell and 64.6% when it rose. Limits: 21-day returns are mostly noise; universe is 60 of today's large caps (survivorship bias) and one country; the backtest ignores taxes, market impact and slippage beyond a flat cost. Next: point-in-time fundamentals, a market-relative target, a larger universe including delisted names, a controlled paper-trading period.</a:t>
+            </a:r>
+          </a:p>
+        </p:txBody>
+      </p:sp>
+      <p:sp>
+        <p:nvSpPr>
+          <p:cNvPr id="4" name="Slide Number Placeholder 3"/>
+          <p:cNvSpPr>
+            <a:spLocks noGrp="1"/>
+          </p:cNvSpPr>
+          <p:nvPr>
+            <p:ph type="sldNum" idx="5" sz="quarter"/>
+          </p:nvPr>
+        </p:nvSpPr>
+        <p:spPr/>
+      </p:sp>
+    </p:spTree>
+  </p:cSld>
+  <p:clrMapOvr>
+    <a:masterClrMapping/>
+  </p:clrMapOvr>
+</p:notes>
+</file>
+
+<file path=ppt/notesSlides/notesSlide7.xml><?xml version="1.0" encoding="utf-8"?>
+<p:notes xmlns:a="http://schemas.openxmlformats.org/drawingml/2006/main" xmlns:p="http://schemas.openxmlformats.org/presentationml/2006/main" xmlns:r="http://schemas.openxmlformats.org/officeDocument/2006/relationships">
+  <p:cSld>
+    <p:spTree>
+      <p:nvGrpSpPr>
+        <p:cNvPr id="1" name=""/>
+        <p:cNvGrpSpPr/>
+        <p:nvPr/>
+      </p:nvGrpSpPr>
+      <p:grpSpPr>
+        <a:xfrm>
+          <a:off x="0" y="0"/>
+          <a:ext cx="0" cy="0"/>
+          <a:chOff x="0" y="0"/>
+          <a:chExt cx="0" cy="0"/>
+        </a:xfrm>
+      </p:grpSpPr>
+      <p:sp>
+        <p:nvSpPr>
+          <p:cNvPr id="2" name="Slide Image Placeholder 1"/>
+          <p:cNvSpPr>
+            <a:spLocks noGrp="1"/>
+          </p:cNvSpPr>
+          <p:nvPr>
+            <p:ph type="sldImg" idx="2"/>
+          </p:nvPr>
+        </p:nvSpPr>
+        <p:spPr/>
+      </p:sp>
+      <p:sp>
+        <p:nvSpPr>
+          <p:cNvPr id="3" name="Notes Placeholder 2"/>
+          <p:cNvSpPr>
+            <a:spLocks noGrp="1"/>
+          </p:cNvSpPr>
+          <p:nvPr>
+            <p:ph type="body" idx="3" sz="quarter"/>
+          </p:nvPr>
+        </p:nvSpPr>
+        <p:spPr/>
+        <p:txBody>
+          <a:bodyPr/>
+          <a:lstStyle/>
+          <a:p>
+            <a:r>
+              <a:t>Live demo</a:t>
+            </a:r>
+          </a:p>
+          <a:p>
+            <a:r>
+              <a:t>Section: Demo</a:t>
+            </a:r>
+          </a:p>
+          <a:p/>
+          <a:p>
+            <a:r>
+              <a:t>Live demo steps: profile intake, ranked book, stock research with SHAP, portfolio lab, model report. Live app https://fn.iimbg.com . Landing page https://fin.iimbg.com . Code https://github.com/build-with-bala/ai-portfolio-advisor . Engineering: built with Claude Code and verified by the team; 22 automated tests; one command (python -m src.model) retrains from the committed data snapshot in about a minute; prompts, failures and fixes are in docs/VIBE_CODING_LOG.md. Team: Group 5: B Gokul Vaigundh (DBM/1015/03), Balaji G (DBM/1016/03), Shashaanth NC (DBM/1070/03).</a:t>
+            </a:r>
+          </a:p>
+          <a:p/>
+          <a:p>
+            <a:r>
+              <a:t>PowerPoint cannot carry the HTML animations and builds; the animated version is at https://fin.iimbg.com/deck/</a:t>
+            </a:r>
+          </a:p>
+        </p:txBody>
+      </p:sp>
+      <p:sp>
+        <p:nvSpPr>
+          <p:cNvPr id="4" name="Slide Number Placeholder 3"/>
+          <p:cNvSpPr>
+            <a:spLocks noGrp="1"/>
+          </p:cNvSpPr>
+          <p:nvPr>
+            <p:ph type="sldNum" idx="5" sz="quarter"/>
+          </p:nvPr>
+        </p:nvSpPr>
+        <p:spPr/>
+      </p:sp>
+    </p:spTree>
+  </p:cSld>
+  <p:clrMapOvr>
+    <a:masterClrMapping/>
+  </p:clrMapOvr>
+</p:notes>
 </file>
 
 <file path=ppt/slideLayouts/slideLayout1.xml><?xml version="1.0" encoding="utf-8"?>
@@ -3099,786 +4017,30 @@
         <p:nvPr/>
       </p:nvGrpSpPr>
       <p:grpSpPr/>
-      <p:sp>
-        <p:nvSpPr>
-          <p:cNvPr id="2" name="Rectangle 1"/>
-          <p:cNvSpPr/>
+      <p:pic>
+        <p:nvPicPr>
+          <p:cNvPr id="2" name="Slide 1: A forecast is a range." descr="A forecast is a range. AI Portfolio Advisor: profile-aware NSE stock recommendations with a pessimistic, median and optimistic (P10, P50, P90) 21-trading-day forecast from three LightGBM quantile models, for 60 NSE stocks. Agenda: 5-minute executive pitch, 10-minute technical deep dive, live demo. Group 5: B Gokul Vaigundh (DBM/1015/03), Balaji G (DBM/1016/03), Shashaanth NC (DBM/1070/03)."/>
+          <p:cNvPicPr>
+            <a:picLocks noChangeAspect="1"/>
+          </p:cNvPicPr>
           <p:nvPr/>
-        </p:nvSpPr>
+        </p:nvPicPr>
+        <p:blipFill>
+          <a:blip r:embed="rId2"/>
+          <a:stretch>
+            <a:fillRect/>
+          </a:stretch>
+        </p:blipFill>
         <p:spPr>
           <a:xfrm>
             <a:off x="0" y="0"/>
-            <a:ext cx="12191695" cy="6858000"/>
+            <a:ext cx="18288000" cy="10287000"/>
           </a:xfrm>
           <a:prstGeom prst="rect">
             <a:avLst/>
           </a:prstGeom>
-          <a:solidFill>
-            <a:srgbClr val="141B3C"/>
-          </a:solidFill>
-          <a:ln>
-            <a:noFill/>
-          </a:ln>
         </p:spPr>
-        <p:style>
-          <a:lnRef idx="1">
-            <a:schemeClr val="accent1"/>
-          </a:lnRef>
-          <a:fillRef idx="3">
-            <a:schemeClr val="accent1"/>
-          </a:fillRef>
-          <a:effectRef idx="2">
-            <a:schemeClr val="accent1"/>
-          </a:effectRef>
-          <a:fontRef idx="minor">
-            <a:schemeClr val="lt1"/>
-          </a:fontRef>
-        </p:style>
-        <p:txBody>
-          <a:bodyPr rtlCol="0" anchor="ctr"/>
-          <a:lstStyle/>
-          <a:p>
-            <a:pPr algn="ctr"/>
-          </a:p>
-        </p:txBody>
-      </p:sp>
-      <p:sp>
-        <p:nvSpPr>
-          <p:cNvPr id="3" name="TextBox 2"/>
-          <p:cNvSpPr txBox="1"/>
-          <p:nvPr/>
-        </p:nvSpPr>
-        <p:spPr>
-          <a:xfrm>
-            <a:off x="731520" y="2103120"/>
-            <a:ext cx="10515600" cy="2743200"/>
-          </a:xfrm>
-          <a:prstGeom prst="rect">
-            <a:avLst/>
-          </a:prstGeom>
-          <a:noFill/>
-        </p:spPr>
-        <p:txBody>
-          <a:bodyPr wrap="none">
-            <a:spAutoFit/>
-          </a:bodyPr>
-          <a:lstStyle/>
-          <a:p>
-            <a:pPr>
-              <a:defRPr sz="5400" b="1">
-                <a:solidFill>
-                  <a:srgbClr val="FFFFFF"/>
-                </a:solidFill>
-              </a:defRPr>
-            </a:pPr>
-            <a:r>
-              <a:t>AI Portfolio Advisor</a:t>
-            </a:r>
-          </a:p>
-          <a:p>
-            <a:pPr>
-              <a:spcBef>
-                <a:spcPts val="1400"/>
-              </a:spcBef>
-              <a:defRPr sz="2400">
-                <a:solidFill>
-                  <a:srgbClr val="E09F1F"/>
-                </a:solidFill>
-              </a:defRPr>
-            </a:pPr>
-            <a:r>
-              <a:t>A forecast is a range: profile-aware stock recommendations with visible uncertainty</a:t>
-            </a:r>
-          </a:p>
-          <a:p>
-            <a:pPr>
-              <a:spcBef>
-                <a:spcPts val="1400"/>
-              </a:spcBef>
-              <a:defRPr sz="1600">
-                <a:solidFill>
-                  <a:srgbClr val="DCDCE6"/>
-                </a:solidFill>
-              </a:defRPr>
-            </a:pPr>
-            <a:r>
-              <a:t>Applied AI &amp; Machine Learning Capstone | AI and ML for Digital Business Managers</a:t>
-            </a:r>
-          </a:p>
-          <a:p>
-            <a:pPr>
-              <a:spcBef>
-                <a:spcPts val="1400"/>
-              </a:spcBef>
-              <a:defRPr sz="1600">
-                <a:solidFill>
-                  <a:srgbClr val="DCDCE6"/>
-                </a:solidFill>
-              </a:defRPr>
-            </a:pPr>
-            <a:r>
-              <a:t>https://fn.iimbg.com   |   https://github.com/build-with-bala/ai-portfolio-advisor</a:t>
-            </a:r>
-          </a:p>
-        </p:txBody>
-      </p:sp>
-    </p:spTree>
-  </p:cSld>
-  <p:clrMapOvr>
-    <a:masterClrMapping/>
-  </p:clrMapOvr>
-</p:sld>
-</file>
-
-<file path=ppt/slides/slide10.xml><?xml version="1.0" encoding="utf-8"?>
-<p:sld xmlns:a="http://schemas.openxmlformats.org/drawingml/2006/main" xmlns:p="http://schemas.openxmlformats.org/presentationml/2006/main" xmlns:r="http://schemas.openxmlformats.org/officeDocument/2006/relationships">
-  <p:cSld>
-    <p:spTree>
-      <p:nvGrpSpPr>
-        <p:cNvPr id="1" name=""/>
-        <p:cNvGrpSpPr/>
-        <p:nvPr/>
-      </p:nvGrpSpPr>
-      <p:grpSpPr/>
-      <p:sp>
-        <p:nvSpPr>
-          <p:cNvPr id="2" name="Rectangle 1"/>
-          <p:cNvSpPr/>
-          <p:nvPr/>
-        </p:nvSpPr>
-        <p:spPr>
-          <a:xfrm>
-            <a:off x="0" y="0"/>
-            <a:ext cx="12191695" cy="1143000"/>
-          </a:xfrm>
-          <a:prstGeom prst="rect">
-            <a:avLst/>
-          </a:prstGeom>
-          <a:solidFill>
-            <a:srgbClr val="141B3C"/>
-          </a:solidFill>
-          <a:ln>
-            <a:noFill/>
-          </a:ln>
-        </p:spPr>
-        <p:style>
-          <a:lnRef idx="1">
-            <a:schemeClr val="accent1"/>
-          </a:lnRef>
-          <a:fillRef idx="3">
-            <a:schemeClr val="accent1"/>
-          </a:fillRef>
-          <a:effectRef idx="2">
-            <a:schemeClr val="accent1"/>
-          </a:effectRef>
-          <a:fontRef idx="minor">
-            <a:schemeClr val="lt1"/>
-          </a:fontRef>
-        </p:style>
-        <p:txBody>
-          <a:bodyPr rtlCol="0" anchor="ctr"/>
-          <a:lstStyle/>
-          <a:p>
-            <a:pPr algn="ctr"/>
-          </a:p>
-        </p:txBody>
-      </p:sp>
-      <p:sp>
-        <p:nvSpPr>
-          <p:cNvPr id="3" name="TextBox 2"/>
-          <p:cNvSpPr txBox="1"/>
-          <p:nvPr/>
-        </p:nvSpPr>
-        <p:spPr>
-          <a:xfrm>
-            <a:off x="548640" y="256032"/>
-            <a:ext cx="10058400" cy="731520"/>
-          </a:xfrm>
-          <a:prstGeom prst="rect">
-            <a:avLst/>
-          </a:prstGeom>
-          <a:noFill/>
-        </p:spPr>
-        <p:txBody>
-          <a:bodyPr wrap="none">
-            <a:spAutoFit/>
-          </a:bodyPr>
-          <a:lstStyle/>
-          <a:p>
-            <a:pPr>
-              <a:defRPr sz="3000" b="1">
-                <a:solidFill>
-                  <a:srgbClr val="FFFFFF"/>
-                </a:solidFill>
-              </a:defRPr>
-            </a:pPr>
-            <a:r>
-              <a:t>Limits and next steps</a:t>
-            </a:r>
-          </a:p>
-        </p:txBody>
-      </p:sp>
-      <p:sp>
-        <p:nvSpPr>
-          <p:cNvPr id="4" name="TextBox 3"/>
-          <p:cNvSpPr txBox="1"/>
-          <p:nvPr/>
-        </p:nvSpPr>
-        <p:spPr>
-          <a:xfrm>
-            <a:off x="9418320" y="384048"/>
-            <a:ext cx="2377440" cy="457200"/>
-          </a:xfrm>
-          <a:prstGeom prst="rect">
-            <a:avLst/>
-          </a:prstGeom>
-          <a:noFill/>
-        </p:spPr>
-        <p:txBody>
-          <a:bodyPr wrap="none">
-            <a:spAutoFit/>
-          </a:bodyPr>
-          <a:lstStyle/>
-          <a:p>
-            <a:pPr>
-              <a:defRPr sz="1400">
-                <a:solidFill>
-                  <a:srgbClr val="E09F1F"/>
-                </a:solidFill>
-              </a:defRPr>
-            </a:pPr>
-            <a:r>
-              <a:t>Technical deep dive</a:t>
-            </a:r>
-          </a:p>
-        </p:txBody>
-      </p:sp>
-      <p:sp>
-        <p:nvSpPr>
-          <p:cNvPr id="5" name="TextBox 4"/>
-          <p:cNvSpPr txBox="1"/>
-          <p:nvPr/>
-        </p:nvSpPr>
-        <p:spPr>
-          <a:xfrm>
-            <a:off x="548640" y="1463040"/>
-            <a:ext cx="11064240" cy="5029200"/>
-          </a:xfrm>
-          <a:prstGeom prst="rect">
-            <a:avLst/>
-          </a:prstGeom>
-          <a:noFill/>
-        </p:spPr>
-        <p:txBody>
-          <a:bodyPr wrap="square">
-            <a:spAutoFit/>
-          </a:bodyPr>
-          <a:lstStyle/>
-          <a:p>
-            <a:pPr>
-              <a:spcAft>
-                <a:spcPts val="1200"/>
-              </a:spcAft>
-              <a:defRPr sz="2000">
-                <a:solidFill>
-                  <a:srgbClr val="222222"/>
-                </a:solidFill>
-              </a:defRPr>
-            </a:pPr>
-            <a:r>
-              <a:t>•  Returns over 21 days are mostly noise; the model explains a small part of the differences between stocks.</a:t>
-            </a:r>
-          </a:p>
-          <a:p>
-            <a:pPr>
-              <a:spcAft>
-                <a:spcPts val="1200"/>
-              </a:spcAft>
-              <a:defRPr sz="2000">
-                <a:solidFill>
-                  <a:srgbClr val="222222"/>
-                </a:solidFill>
-              </a:defRPr>
-            </a:pPr>
-            <a:r>
-              <a:t>•  Universe is 60 of today's large caps (survivorship bias) and one country.</a:t>
-            </a:r>
-          </a:p>
-          <a:p>
-            <a:pPr>
-              <a:spcAft>
-                <a:spcPts val="1200"/>
-              </a:spcAft>
-              <a:defRPr sz="2000">
-                <a:solidFill>
-                  <a:srgbClr val="222222"/>
-                </a:solidFill>
-              </a:defRPr>
-            </a:pPr>
-            <a:r>
-              <a:t>•  The backtest ignores taxes, market impact and slippage beyond the flat cost assumption.</a:t>
-            </a:r>
-          </a:p>
-          <a:p>
-            <a:pPr>
-              <a:spcAft>
-                <a:spcPts val="1200"/>
-              </a:spcAft>
-              <a:defRPr sz="2000">
-                <a:solidFill>
-                  <a:srgbClr val="222222"/>
-                </a:solidFill>
-              </a:defRPr>
-            </a:pPr>
-            <a:r>
-              <a:t>•  Fundamental scores in the app use today's ratios and are not part of the validated forecast.</a:t>
-            </a:r>
-          </a:p>
-          <a:p>
-            <a:pPr>
-              <a:spcAft>
-                <a:spcPts val="1200"/>
-              </a:spcAft>
-              <a:defRPr sz="2000">
-                <a:solidFill>
-                  <a:srgbClr val="222222"/>
-                </a:solidFill>
-              </a:defRPr>
-            </a:pPr>
-            <a:r>
-              <a:t>•  Next: point-in-time fundamentals, a market-relative target, a larger universe including delisted names, and a controlled paper-trading period.</a:t>
-            </a:r>
-          </a:p>
-        </p:txBody>
-      </p:sp>
-    </p:spTree>
-  </p:cSld>
-  <p:clrMapOvr>
-    <a:masterClrMapping/>
-  </p:clrMapOvr>
-</p:sld>
-</file>
-
-<file path=ppt/slides/slide11.xml><?xml version="1.0" encoding="utf-8"?>
-<p:sld xmlns:a="http://schemas.openxmlformats.org/drawingml/2006/main" xmlns:p="http://schemas.openxmlformats.org/presentationml/2006/main" xmlns:r="http://schemas.openxmlformats.org/officeDocument/2006/relationships">
-  <p:cSld>
-    <p:spTree>
-      <p:nvGrpSpPr>
-        <p:cNvPr id="1" name=""/>
-        <p:cNvGrpSpPr/>
-        <p:nvPr/>
-      </p:nvGrpSpPr>
-      <p:grpSpPr/>
-      <p:sp>
-        <p:nvSpPr>
-          <p:cNvPr id="2" name="Rectangle 1"/>
-          <p:cNvSpPr/>
-          <p:nvPr/>
-        </p:nvSpPr>
-        <p:spPr>
-          <a:xfrm>
-            <a:off x="0" y="0"/>
-            <a:ext cx="12191695" cy="1143000"/>
-          </a:xfrm>
-          <a:prstGeom prst="rect">
-            <a:avLst/>
-          </a:prstGeom>
-          <a:solidFill>
-            <a:srgbClr val="141B3C"/>
-          </a:solidFill>
-          <a:ln>
-            <a:noFill/>
-          </a:ln>
-        </p:spPr>
-        <p:style>
-          <a:lnRef idx="1">
-            <a:schemeClr val="accent1"/>
-          </a:lnRef>
-          <a:fillRef idx="3">
-            <a:schemeClr val="accent1"/>
-          </a:fillRef>
-          <a:effectRef idx="2">
-            <a:schemeClr val="accent1"/>
-          </a:effectRef>
-          <a:fontRef idx="minor">
-            <a:schemeClr val="lt1"/>
-          </a:fontRef>
-        </p:style>
-        <p:txBody>
-          <a:bodyPr rtlCol="0" anchor="ctr"/>
-          <a:lstStyle/>
-          <a:p>
-            <a:pPr algn="ctr"/>
-          </a:p>
-        </p:txBody>
-      </p:sp>
-      <p:sp>
-        <p:nvSpPr>
-          <p:cNvPr id="3" name="TextBox 2"/>
-          <p:cNvSpPr txBox="1"/>
-          <p:nvPr/>
-        </p:nvSpPr>
-        <p:spPr>
-          <a:xfrm>
-            <a:off x="548640" y="256032"/>
-            <a:ext cx="10058400" cy="731520"/>
-          </a:xfrm>
-          <a:prstGeom prst="rect">
-            <a:avLst/>
-          </a:prstGeom>
-          <a:noFill/>
-        </p:spPr>
-        <p:txBody>
-          <a:bodyPr wrap="none">
-            <a:spAutoFit/>
-          </a:bodyPr>
-          <a:lstStyle/>
-          <a:p>
-            <a:pPr>
-              <a:defRPr sz="3000" b="1">
-                <a:solidFill>
-                  <a:srgbClr val="FFFFFF"/>
-                </a:solidFill>
-              </a:defRPr>
-            </a:pPr>
-            <a:r>
-              <a:t>Repository and reproducibility</a:t>
-            </a:r>
-          </a:p>
-        </p:txBody>
-      </p:sp>
-      <p:sp>
-        <p:nvSpPr>
-          <p:cNvPr id="4" name="TextBox 3"/>
-          <p:cNvSpPr txBox="1"/>
-          <p:nvPr/>
-        </p:nvSpPr>
-        <p:spPr>
-          <a:xfrm>
-            <a:off x="9418320" y="384048"/>
-            <a:ext cx="2377440" cy="457200"/>
-          </a:xfrm>
-          <a:prstGeom prst="rect">
-            <a:avLst/>
-          </a:prstGeom>
-          <a:noFill/>
-        </p:spPr>
-        <p:txBody>
-          <a:bodyPr wrap="none">
-            <a:spAutoFit/>
-          </a:bodyPr>
-          <a:lstStyle/>
-          <a:p>
-            <a:pPr>
-              <a:defRPr sz="1400">
-                <a:solidFill>
-                  <a:srgbClr val="E09F1F"/>
-                </a:solidFill>
-              </a:defRPr>
-            </a:pPr>
-            <a:r>
-              <a:t>Repository</a:t>
-            </a:r>
-          </a:p>
-        </p:txBody>
-      </p:sp>
-      <p:sp>
-        <p:nvSpPr>
-          <p:cNvPr id="5" name="TextBox 4"/>
-          <p:cNvSpPr txBox="1"/>
-          <p:nvPr/>
-        </p:nvSpPr>
-        <p:spPr>
-          <a:xfrm>
-            <a:off x="548640" y="1463040"/>
-            <a:ext cx="11064240" cy="5029200"/>
-          </a:xfrm>
-          <a:prstGeom prst="rect">
-            <a:avLst/>
-          </a:prstGeom>
-          <a:noFill/>
-        </p:spPr>
-        <p:txBody>
-          <a:bodyPr wrap="square">
-            <a:spAutoFit/>
-          </a:bodyPr>
-          <a:lstStyle/>
-          <a:p>
-            <a:pPr>
-              <a:spcAft>
-                <a:spcPts val="1200"/>
-              </a:spcAft>
-              <a:defRPr sz="2000">
-                <a:solidFill>
-                  <a:srgbClr val="222222"/>
-                </a:solidFill>
-              </a:defRPr>
-            </a:pPr>
-            <a:r>
-              <a:t>•  Layout: src/data.py, src/model.py, app.py, requirements.txt, tests/ (17 tests), reports/, docs/.</a:t>
-            </a:r>
-          </a:p>
-          <a:p>
-            <a:pPr>
-              <a:spcAft>
-                <a:spcPts val="1200"/>
-              </a:spcAft>
-              <a:defRPr sz="2000">
-                <a:solidFill>
-                  <a:srgbClr val="222222"/>
-                </a:solidFill>
-              </a:defRPr>
-            </a:pPr>
-            <a:r>
-              <a:t>•  Reproduce: pip install -r requirements.txt; python -m src.model (trains from the committed data snapshot in about a minute); streamlit run app.py.</a:t>
-            </a:r>
-          </a:p>
-          <a:p>
-            <a:pPr>
-              <a:spcAft>
-                <a:spcPts val="1200"/>
-              </a:spcAft>
-              <a:defRPr sz="2000">
-                <a:solidFill>
-                  <a:srgbClr val="222222"/>
-                </a:solidFill>
-              </a:defRPr>
-            </a:pPr>
-            <a:r>
-              <a:t>•  Vibe Coding Log: docs/VIBE_CODING_LOG.md.</a:t>
-            </a:r>
-          </a:p>
-        </p:txBody>
-      </p:sp>
-    </p:spTree>
-  </p:cSld>
-  <p:clrMapOvr>
-    <a:masterClrMapping/>
-  </p:clrMapOvr>
-</p:sld>
-</file>
-
-<file path=ppt/slides/slide12.xml><?xml version="1.0" encoding="utf-8"?>
-<p:sld xmlns:a="http://schemas.openxmlformats.org/drawingml/2006/main" xmlns:p="http://schemas.openxmlformats.org/presentationml/2006/main" xmlns:r="http://schemas.openxmlformats.org/officeDocument/2006/relationships">
-  <p:cSld>
-    <p:spTree>
-      <p:nvGrpSpPr>
-        <p:cNvPr id="1" name=""/>
-        <p:cNvGrpSpPr/>
-        <p:nvPr/>
-      </p:nvGrpSpPr>
-      <p:grpSpPr/>
-      <p:sp>
-        <p:nvSpPr>
-          <p:cNvPr id="2" name="Rectangle 1"/>
-          <p:cNvSpPr/>
-          <p:nvPr/>
-        </p:nvSpPr>
-        <p:spPr>
-          <a:xfrm>
-            <a:off x="0" y="0"/>
-            <a:ext cx="12191695" cy="1143000"/>
-          </a:xfrm>
-          <a:prstGeom prst="rect">
-            <a:avLst/>
-          </a:prstGeom>
-          <a:solidFill>
-            <a:srgbClr val="141B3C"/>
-          </a:solidFill>
-          <a:ln>
-            <a:noFill/>
-          </a:ln>
-        </p:spPr>
-        <p:style>
-          <a:lnRef idx="1">
-            <a:schemeClr val="accent1"/>
-          </a:lnRef>
-          <a:fillRef idx="3">
-            <a:schemeClr val="accent1"/>
-          </a:fillRef>
-          <a:effectRef idx="2">
-            <a:schemeClr val="accent1"/>
-          </a:effectRef>
-          <a:fontRef idx="minor">
-            <a:schemeClr val="lt1"/>
-          </a:fontRef>
-        </p:style>
-        <p:txBody>
-          <a:bodyPr rtlCol="0" anchor="ctr"/>
-          <a:lstStyle/>
-          <a:p>
-            <a:pPr algn="ctr"/>
-          </a:p>
-        </p:txBody>
-      </p:sp>
-      <p:sp>
-        <p:nvSpPr>
-          <p:cNvPr id="3" name="TextBox 2"/>
-          <p:cNvSpPr txBox="1"/>
-          <p:nvPr/>
-        </p:nvSpPr>
-        <p:spPr>
-          <a:xfrm>
-            <a:off x="548640" y="256032"/>
-            <a:ext cx="10058400" cy="731520"/>
-          </a:xfrm>
-          <a:prstGeom prst="rect">
-            <a:avLst/>
-          </a:prstGeom>
-          <a:noFill/>
-        </p:spPr>
-        <p:txBody>
-          <a:bodyPr wrap="none">
-            <a:spAutoFit/>
-          </a:bodyPr>
-          <a:lstStyle/>
-          <a:p>
-            <a:pPr>
-              <a:defRPr sz="3000" b="1">
-                <a:solidFill>
-                  <a:srgbClr val="FFFFFF"/>
-                </a:solidFill>
-              </a:defRPr>
-            </a:pPr>
-            <a:r>
-              <a:t>Live demonstration</a:t>
-            </a:r>
-          </a:p>
-        </p:txBody>
-      </p:sp>
-      <p:sp>
-        <p:nvSpPr>
-          <p:cNvPr id="4" name="TextBox 3"/>
-          <p:cNvSpPr txBox="1"/>
-          <p:nvPr/>
-        </p:nvSpPr>
-        <p:spPr>
-          <a:xfrm>
-            <a:off x="9418320" y="384048"/>
-            <a:ext cx="2377440" cy="457200"/>
-          </a:xfrm>
-          <a:prstGeom prst="rect">
-            <a:avLst/>
-          </a:prstGeom>
-          <a:noFill/>
-        </p:spPr>
-        <p:txBody>
-          <a:bodyPr wrap="none">
-            <a:spAutoFit/>
-          </a:bodyPr>
-          <a:lstStyle/>
-          <a:p>
-            <a:pPr>
-              <a:defRPr sz="1400">
-                <a:solidFill>
-                  <a:srgbClr val="E09F1F"/>
-                </a:solidFill>
-              </a:defRPr>
-            </a:pPr>
-            <a:r>
-              <a:t>Demo</a:t>
-            </a:r>
-          </a:p>
-        </p:txBody>
-      </p:sp>
-      <p:sp>
-        <p:nvSpPr>
-          <p:cNvPr id="5" name="TextBox 4"/>
-          <p:cNvSpPr txBox="1"/>
-          <p:nvPr/>
-        </p:nvSpPr>
-        <p:spPr>
-          <a:xfrm>
-            <a:off x="548640" y="1463040"/>
-            <a:ext cx="11064240" cy="5029200"/>
-          </a:xfrm>
-          <a:prstGeom prst="rect">
-            <a:avLst/>
-          </a:prstGeom>
-          <a:noFill/>
-        </p:spPr>
-        <p:txBody>
-          <a:bodyPr wrap="square">
-            <a:spAutoFit/>
-          </a:bodyPr>
-          <a:lstStyle/>
-          <a:p>
-            <a:pPr>
-              <a:spcAft>
-                <a:spcPts val="1200"/>
-              </a:spcAft>
-              <a:defRPr sz="2000">
-                <a:solidFill>
-                  <a:srgbClr val="222222"/>
-                </a:solidFill>
-              </a:defRPr>
-            </a:pPr>
-            <a:r>
-              <a:t>•  Open https://fn.iimbg.com.</a:t>
-            </a:r>
-          </a:p>
-          <a:p>
-            <a:pPr>
-              <a:spcAft>
-                <a:spcPts val="1200"/>
-              </a:spcAft>
-              <a:defRPr sz="2000">
-                <a:solidFill>
-                  <a:srgbClr val="222222"/>
-                </a:solidFill>
-              </a:defRPr>
-            </a:pPr>
-            <a:r>
-              <a:t>•  Set a Conservative profile with Rs 5,00,000: read the ranked book and the cash remainder.</a:t>
-            </a:r>
-          </a:p>
-          <a:p>
-            <a:pPr>
-              <a:spcAft>
-                <a:spcPts val="1200"/>
-              </a:spcAft>
-              <a:defRPr sz="2000">
-                <a:solidFill>
-                  <a:srgbClr val="222222"/>
-                </a:solidFill>
-              </a:defRPr>
-            </a:pPr>
-            <a:r>
-              <a:t>•  Switch to Aggressive: the same evidence, different weights and caps, different book.</a:t>
-            </a:r>
-          </a:p>
-          <a:p>
-            <a:pPr>
-              <a:spcAft>
-                <a:spcPts val="1200"/>
-              </a:spcAft>
-              <a:defRPr sz="2000">
-                <a:solidFill>
-                  <a:srgbClr val="222222"/>
-                </a:solidFill>
-              </a:defRPr>
-            </a:pPr>
-            <a:r>
-              <a:t>•  Open one stock: P10 / P50 / P90 range and its SHAP drivers.</a:t>
-            </a:r>
-          </a:p>
-          <a:p>
-            <a:pPr>
-              <a:spcAft>
-                <a:spcPts val="1200"/>
-              </a:spcAft>
-              <a:defRPr sz="2000">
-                <a:solidFill>
-                  <a:srgbClr val="222222"/>
-                </a:solidFill>
-              </a:defRPr>
-            </a:pPr>
-            <a:r>
-              <a:t>•  Model report tab: cross-validation table, hold-out results, backtest, error analysis.</a:t>
-            </a:r>
-          </a:p>
-        </p:txBody>
-      </p:sp>
+      </p:pic>
     </p:spTree>
   </p:cSld>
   <p:clrMapOvr>
@@ -3897,202 +4059,30 @@
         <p:nvPr/>
       </p:nvGrpSpPr>
       <p:grpSpPr/>
-      <p:sp>
-        <p:nvSpPr>
-          <p:cNvPr id="2" name="Rectangle 1"/>
-          <p:cNvSpPr/>
+      <p:pic>
+        <p:nvPicPr>
+          <p:cNvPr id="2" name="Slide 2: Advisers get a tip. They need the range, the reason and the size." descr="Advisers get a tip. They need the range, the reason and the size. Target user: an independent wealth adviser or self-directed investor in India who reviews a portfolio monthly. Today picks come from tips and single-number targets with no view of the range of outcomes or fit with risk tolerance. The product takes a risk profile and capital, blends four evidence pillars (technical score, fundamental score, model forecast, risk fit) by profile weights, and returns a ranked book marked STRONG BUY / BUY / WATCH / PASS with a P10/P50/P90 21-day return, a position size from Hierarchical Risk Parity and SHAP drivers per stock."/>
+          <p:cNvPicPr>
+            <a:picLocks noChangeAspect="1"/>
+          </p:cNvPicPr>
           <p:nvPr/>
-        </p:nvSpPr>
+        </p:nvPicPr>
+        <p:blipFill>
+          <a:blip r:embed="rId2"/>
+          <a:stretch>
+            <a:fillRect/>
+          </a:stretch>
+        </p:blipFill>
         <p:spPr>
           <a:xfrm>
             <a:off x="0" y="0"/>
-            <a:ext cx="12191695" cy="1143000"/>
+            <a:ext cx="18288000" cy="10287000"/>
           </a:xfrm>
           <a:prstGeom prst="rect">
             <a:avLst/>
           </a:prstGeom>
-          <a:solidFill>
-            <a:srgbClr val="141B3C"/>
-          </a:solidFill>
-          <a:ln>
-            <a:noFill/>
-          </a:ln>
         </p:spPr>
-        <p:style>
-          <a:lnRef idx="1">
-            <a:schemeClr val="accent1"/>
-          </a:lnRef>
-          <a:fillRef idx="3">
-            <a:schemeClr val="accent1"/>
-          </a:fillRef>
-          <a:effectRef idx="2">
-            <a:schemeClr val="accent1"/>
-          </a:effectRef>
-          <a:fontRef idx="minor">
-            <a:schemeClr val="lt1"/>
-          </a:fontRef>
-        </p:style>
-        <p:txBody>
-          <a:bodyPr rtlCol="0" anchor="ctr"/>
-          <a:lstStyle/>
-          <a:p>
-            <a:pPr algn="ctr"/>
-          </a:p>
-        </p:txBody>
-      </p:sp>
-      <p:sp>
-        <p:nvSpPr>
-          <p:cNvPr id="3" name="TextBox 2"/>
-          <p:cNvSpPr txBox="1"/>
-          <p:nvPr/>
-        </p:nvSpPr>
-        <p:spPr>
-          <a:xfrm>
-            <a:off x="548640" y="256032"/>
-            <a:ext cx="10058400" cy="731520"/>
-          </a:xfrm>
-          <a:prstGeom prst="rect">
-            <a:avLst/>
-          </a:prstGeom>
-          <a:noFill/>
-        </p:spPr>
-        <p:txBody>
-          <a:bodyPr wrap="none">
-            <a:spAutoFit/>
-          </a:bodyPr>
-          <a:lstStyle/>
-          <a:p>
-            <a:pPr>
-              <a:defRPr sz="3000" b="1">
-                <a:solidFill>
-                  <a:srgbClr val="FFFFFF"/>
-                </a:solidFill>
-              </a:defRPr>
-            </a:pPr>
-            <a:r>
-              <a:t>Problem and user</a:t>
-            </a:r>
-          </a:p>
-        </p:txBody>
-      </p:sp>
-      <p:sp>
-        <p:nvSpPr>
-          <p:cNvPr id="4" name="TextBox 3"/>
-          <p:cNvSpPr txBox="1"/>
-          <p:nvPr/>
-        </p:nvSpPr>
-        <p:spPr>
-          <a:xfrm>
-            <a:off x="9418320" y="384048"/>
-            <a:ext cx="2377440" cy="457200"/>
-          </a:xfrm>
-          <a:prstGeom prst="rect">
-            <a:avLst/>
-          </a:prstGeom>
-          <a:noFill/>
-        </p:spPr>
-        <p:txBody>
-          <a:bodyPr wrap="none">
-            <a:spAutoFit/>
-          </a:bodyPr>
-          <a:lstStyle/>
-          <a:p>
-            <a:pPr>
-              <a:defRPr sz="1400">
-                <a:solidFill>
-                  <a:srgbClr val="E09F1F"/>
-                </a:solidFill>
-              </a:defRPr>
-            </a:pPr>
-            <a:r>
-              <a:t>Executive pitch</a:t>
-            </a:r>
-          </a:p>
-        </p:txBody>
-      </p:sp>
-      <p:sp>
-        <p:nvSpPr>
-          <p:cNvPr id="5" name="TextBox 4"/>
-          <p:cNvSpPr txBox="1"/>
-          <p:nvPr/>
-        </p:nvSpPr>
-        <p:spPr>
-          <a:xfrm>
-            <a:off x="548640" y="1463040"/>
-            <a:ext cx="11064240" cy="5029200"/>
-          </a:xfrm>
-          <a:prstGeom prst="rect">
-            <a:avLst/>
-          </a:prstGeom>
-          <a:noFill/>
-        </p:spPr>
-        <p:txBody>
-          <a:bodyPr wrap="square">
-            <a:spAutoFit/>
-          </a:bodyPr>
-          <a:lstStyle/>
-          <a:p>
-            <a:pPr>
-              <a:spcAft>
-                <a:spcPts val="1200"/>
-              </a:spcAft>
-              <a:defRPr sz="2000">
-                <a:solidFill>
-                  <a:srgbClr val="222222"/>
-                </a:solidFill>
-              </a:defRPr>
-            </a:pPr>
-            <a:r>
-              <a:t>•  Retail investors and small wealth advisers in India pick stocks from tips and single-number targets, with no view of the range of outcomes or of how a pick fits their risk tolerance.</a:t>
-            </a:r>
-          </a:p>
-          <a:p>
-            <a:pPr>
-              <a:spcAft>
-                <a:spcPts val="1200"/>
-              </a:spcAft>
-              <a:defRPr sz="2000">
-                <a:solidFill>
-                  <a:srgbClr val="222222"/>
-                </a:solidFill>
-              </a:defRPr>
-            </a:pPr>
-            <a:r>
-              <a:t>•  Target user: an independent wealth adviser or self-directed investor who reviews a portfolio monthly.</a:t>
-            </a:r>
-          </a:p>
-          <a:p>
-            <a:pPr>
-              <a:spcAft>
-                <a:spcPts val="1200"/>
-              </a:spcAft>
-              <a:defRPr sz="2000">
-                <a:solidFill>
-                  <a:srgbClr val="222222"/>
-                </a:solidFill>
-              </a:defRPr>
-            </a:pPr>
-            <a:r>
-              <a:t>•  AI Portfolio Advisor takes a risk profile and capital, and returns a ranked book of NSE stocks marked STRONG BUY / BUY / WATCH / PASS, each with a pessimistic, median and optimistic 21-day return, the evidence behind it, and a position size.</a:t>
-            </a:r>
-          </a:p>
-          <a:p>
-            <a:pPr>
-              <a:spcAft>
-                <a:spcPts val="1200"/>
-              </a:spcAft>
-              <a:defRPr sz="2000">
-                <a:solidFill>
-                  <a:srgbClr val="222222"/>
-                </a:solidFill>
-              </a:defRPr>
-            </a:pPr>
-            <a:r>
-              <a:t>•  Working prototype: https://fn.iimbg.com  |  Code: https://github.com/build-with-bala/ai-portfolio-advisor</a:t>
-            </a:r>
-          </a:p>
-        </p:txBody>
-      </p:sp>
+      </p:pic>
     </p:spTree>
   </p:cSld>
   <p:clrMapOvr>
@@ -4111,217 +4101,30 @@
         <p:nvPr/>
       </p:nvGrpSpPr>
       <p:grpSpPr/>
-      <p:sp>
-        <p:nvSpPr>
-          <p:cNvPr id="2" name="Rectangle 1"/>
-          <p:cNvSpPr/>
+      <p:pic>
+        <p:nvPicPr>
+          <p:cNvPr id="2" name="Slide 3: 467 adviser hours back each year: a 483% return on cost." descr="467 adviser hours back each year: a 483% return on cost. ROI is an adviser time-saving case built on stated assumptions: 200 clients x 4 reviews a year = 800 reviews; screening time cut from 45 to 10 minutes saves 35 minutes each = 467 hours a year; at Rs 1,500 per adviser hour that is Rs 7.0 lakh (Rs 700,000); against an assumed running cost of Rs 1.2 lakh a year the return on cost is 483%. Market strategy: free research tool for self-directed investors; paid seat for advisers who need client-ready evidence sheets; brokers as a channel through the existing Upstox / Zerodha live-quote adapters. Not claimed: extra return. Hold-out top-5 strategy returned -4.4% a year against +3.3% for holding all stocks equally."/>
+          <p:cNvPicPr>
+            <a:picLocks noChangeAspect="1"/>
+          </p:cNvPicPr>
           <p:nvPr/>
-        </p:nvSpPr>
+        </p:nvPicPr>
+        <p:blipFill>
+          <a:blip r:embed="rId2"/>
+          <a:stretch>
+            <a:fillRect/>
+          </a:stretch>
+        </p:blipFill>
         <p:spPr>
           <a:xfrm>
             <a:off x="0" y="0"/>
-            <a:ext cx="12191695" cy="1143000"/>
+            <a:ext cx="18288000" cy="10287000"/>
           </a:xfrm>
           <a:prstGeom prst="rect">
             <a:avLst/>
           </a:prstGeom>
-          <a:solidFill>
-            <a:srgbClr val="141B3C"/>
-          </a:solidFill>
-          <a:ln>
-            <a:noFill/>
-          </a:ln>
         </p:spPr>
-        <p:style>
-          <a:lnRef idx="1">
-            <a:schemeClr val="accent1"/>
-          </a:lnRef>
-          <a:fillRef idx="3">
-            <a:schemeClr val="accent1"/>
-          </a:fillRef>
-          <a:effectRef idx="2">
-            <a:schemeClr val="accent1"/>
-          </a:effectRef>
-          <a:fontRef idx="minor">
-            <a:schemeClr val="lt1"/>
-          </a:fontRef>
-        </p:style>
-        <p:txBody>
-          <a:bodyPr rtlCol="0" anchor="ctr"/>
-          <a:lstStyle/>
-          <a:p>
-            <a:pPr algn="ctr"/>
-          </a:p>
-        </p:txBody>
-      </p:sp>
-      <p:sp>
-        <p:nvSpPr>
-          <p:cNvPr id="3" name="TextBox 2"/>
-          <p:cNvSpPr txBox="1"/>
-          <p:nvPr/>
-        </p:nvSpPr>
-        <p:spPr>
-          <a:xfrm>
-            <a:off x="548640" y="256032"/>
-            <a:ext cx="10058400" cy="731520"/>
-          </a:xfrm>
-          <a:prstGeom prst="rect">
-            <a:avLst/>
-          </a:prstGeom>
-          <a:noFill/>
-        </p:spPr>
-        <p:txBody>
-          <a:bodyPr wrap="none">
-            <a:spAutoFit/>
-          </a:bodyPr>
-          <a:lstStyle/>
-          <a:p>
-            <a:pPr>
-              <a:defRPr sz="3000" b="1">
-                <a:solidFill>
-                  <a:srgbClr val="FFFFFF"/>
-                </a:solidFill>
-              </a:defRPr>
-            </a:pPr>
-            <a:r>
-              <a:t>Business value and ROI</a:t>
-            </a:r>
-          </a:p>
-        </p:txBody>
-      </p:sp>
-      <p:sp>
-        <p:nvSpPr>
-          <p:cNvPr id="4" name="TextBox 3"/>
-          <p:cNvSpPr txBox="1"/>
-          <p:nvPr/>
-        </p:nvSpPr>
-        <p:spPr>
-          <a:xfrm>
-            <a:off x="9418320" y="384048"/>
-            <a:ext cx="2377440" cy="457200"/>
-          </a:xfrm>
-          <a:prstGeom prst="rect">
-            <a:avLst/>
-          </a:prstGeom>
-          <a:noFill/>
-        </p:spPr>
-        <p:txBody>
-          <a:bodyPr wrap="none">
-            <a:spAutoFit/>
-          </a:bodyPr>
-          <a:lstStyle/>
-          <a:p>
-            <a:pPr>
-              <a:defRPr sz="1400">
-                <a:solidFill>
-                  <a:srgbClr val="E09F1F"/>
-                </a:solidFill>
-              </a:defRPr>
-            </a:pPr>
-            <a:r>
-              <a:t>Executive pitch</a:t>
-            </a:r>
-          </a:p>
-        </p:txBody>
-      </p:sp>
-      <p:sp>
-        <p:nvSpPr>
-          <p:cNvPr id="5" name="TextBox 4"/>
-          <p:cNvSpPr txBox="1"/>
-          <p:nvPr/>
-        </p:nvSpPr>
-        <p:spPr>
-          <a:xfrm>
-            <a:off x="548640" y="1463040"/>
-            <a:ext cx="11064240" cy="5029200"/>
-          </a:xfrm>
-          <a:prstGeom prst="rect">
-            <a:avLst/>
-          </a:prstGeom>
-          <a:noFill/>
-        </p:spPr>
-        <p:txBody>
-          <a:bodyPr wrap="square">
-            <a:spAutoFit/>
-          </a:bodyPr>
-          <a:lstStyle/>
-          <a:p>
-            <a:pPr>
-              <a:spcAft>
-                <a:spcPts val="1200"/>
-              </a:spcAft>
-              <a:defRPr sz="2000">
-                <a:solidFill>
-                  <a:srgbClr val="222222"/>
-                </a:solidFill>
-              </a:defRPr>
-            </a:pPr>
-            <a:r>
-              <a:t>•  Time saved (assumptions, editable in scripts/build_submission.py): 200 clients x 4 reviews a year, screening time cut from 45 to 10 minutes, adviser time valued at Rs 1,500/hour.</a:t>
-            </a:r>
-          </a:p>
-          <a:p>
-            <a:pPr>
-              <a:spcAft>
-                <a:spcPts val="1200"/>
-              </a:spcAft>
-              <a:defRPr sz="2000">
-                <a:solidFill>
-                  <a:srgbClr val="222222"/>
-                </a:solidFill>
-              </a:defRPr>
-            </a:pPr>
-            <a:r>
-              <a:t>•  That is 467 adviser hours a year, worth Rs 700,000, against an assumed running cost of Rs 120,000 a year: a return of 483% on cost.</a:t>
-            </a:r>
-          </a:p>
-          <a:p>
-            <a:pPr>
-              <a:spcAft>
-                <a:spcPts val="1200"/>
-              </a:spcAft>
-              <a:defRPr sz="2000">
-                <a:solidFill>
-                  <a:srgbClr val="222222"/>
-                </a:solidFill>
-              </a:defRPr>
-            </a:pPr>
-            <a:r>
-              <a:t>•  Risk communication: 82.4% of real 21-day outcomes on unseen data fell inside the model's P10-P90 range, against a target of 80%. A client can be shown an honest range.</a:t>
-            </a:r>
-          </a:p>
-          <a:p>
-            <a:pPr>
-              <a:spcAft>
-                <a:spcPts val="1200"/>
-              </a:spcAft>
-              <a:defRPr sz="2000">
-                <a:solidFill>
-                  <a:srgbClr val="222222"/>
-                </a:solidFill>
-              </a:defRPr>
-            </a:pPr>
-            <a:r>
-              <a:t>•  What we do not claim: extra return. In the hold-out backtest the top-5 strategy returned -4.4% a year against 3.3% for holding all stocks equally (median over 21 start days, after costs). The product is sold on speed, discipline and honest risk ranges, not on beating the market.</a:t>
-            </a:r>
-          </a:p>
-          <a:p>
-            <a:pPr>
-              <a:spcAft>
-                <a:spcPts val="1200"/>
-              </a:spcAft>
-              <a:defRPr sz="2000">
-                <a:solidFill>
-                  <a:srgbClr val="222222"/>
-                </a:solidFill>
-              </a:defRPr>
-            </a:pPr>
-            <a:r>
-              <a:t>•  Market strategy: free research tool for self-directed investors; paid seat for advisers who need client-ready evidence sheets; brokers as a channel through the existing Upstox / Zerodha live-quote adapters.</a:t>
-            </a:r>
-          </a:p>
-        </p:txBody>
-      </p:sp>
+      </p:pic>
     </p:spTree>
   </p:cSld>
   <p:clrMapOvr>
@@ -4340,217 +4143,30 @@
         <p:nvPr/>
       </p:nvGrpSpPr>
       <p:grpSpPr/>
-      <p:sp>
-        <p:nvSpPr>
-          <p:cNvPr id="2" name="Rectangle 1"/>
-          <p:cNvSpPr/>
+      <p:pic>
+        <p:nvPicPr>
+          <p:cNvPr id="2" name="Slide 4: From raw prices to the app, with leakage designed out." descr="From raw prices to the app, with leakage designed out. Architecture: prices -&gt; features -&gt; selection -&gt; purged walk-forward CV -&gt; quantile models -&gt; artifact -&gt; app. src/data.py downloads Yahoo Finance prices, builds 19 candidate features, selects features and defines the splits. src/model.py tunes, cross-validates, trains three LightGBM quantile models, evaluates the hold-out, computes SHAP, backtests and exports data/artifacts.pkl and reports/metrics.json. app.py is the Streamlit interface; src/portfolio_advisor/core.py is the decision engine. Data: 60 liquid NSE large caps, five per sector across 12 sectors, daily adjusted prices 2018-02-19 to 2026-10-08, 118,641 stock-days; label = return over the next 21 trading days. Feature selection: greedy mutual-information relevance minus 0.5 x redundancy on development data only; kept 10 of 19: mkt_vol_21, fracdiff_close, rel_ret_21, volume_surge, mom_126_21, Stoch_K, vol_63, ret_63, OBV_delta, Boll_BW. Company fundamentals were removed from the model because only today's ratios exist, so using them on past dates would leak future information."/>
+          <p:cNvPicPr>
+            <a:picLocks noChangeAspect="1"/>
+          </p:cNvPicPr>
           <p:nvPr/>
-        </p:nvSpPr>
+        </p:nvPicPr>
+        <p:blipFill>
+          <a:blip r:embed="rId2"/>
+          <a:stretch>
+            <a:fillRect/>
+          </a:stretch>
+        </p:blipFill>
         <p:spPr>
           <a:xfrm>
             <a:off x="0" y="0"/>
-            <a:ext cx="12191695" cy="1143000"/>
+            <a:ext cx="18288000" cy="10287000"/>
           </a:xfrm>
           <a:prstGeom prst="rect">
             <a:avLst/>
           </a:prstGeom>
-          <a:solidFill>
-            <a:srgbClr val="141B3C"/>
-          </a:solidFill>
-          <a:ln>
-            <a:noFill/>
-          </a:ln>
         </p:spPr>
-        <p:style>
-          <a:lnRef idx="1">
-            <a:schemeClr val="accent1"/>
-          </a:lnRef>
-          <a:fillRef idx="3">
-            <a:schemeClr val="accent1"/>
-          </a:fillRef>
-          <a:effectRef idx="2">
-            <a:schemeClr val="accent1"/>
-          </a:effectRef>
-          <a:fontRef idx="minor">
-            <a:schemeClr val="lt1"/>
-          </a:fontRef>
-        </p:style>
-        <p:txBody>
-          <a:bodyPr rtlCol="0" anchor="ctr"/>
-          <a:lstStyle/>
-          <a:p>
-            <a:pPr algn="ctr"/>
-          </a:p>
-        </p:txBody>
-      </p:sp>
-      <p:sp>
-        <p:nvSpPr>
-          <p:cNvPr id="3" name="TextBox 2"/>
-          <p:cNvSpPr txBox="1"/>
-          <p:nvPr/>
-        </p:nvSpPr>
-        <p:spPr>
-          <a:xfrm>
-            <a:off x="548640" y="256032"/>
-            <a:ext cx="10058400" cy="731520"/>
-          </a:xfrm>
-          <a:prstGeom prst="rect">
-            <a:avLst/>
-          </a:prstGeom>
-          <a:noFill/>
-        </p:spPr>
-        <p:txBody>
-          <a:bodyPr wrap="none">
-            <a:spAutoFit/>
-          </a:bodyPr>
-          <a:lstStyle/>
-          <a:p>
-            <a:pPr>
-              <a:defRPr sz="3000" b="1">
-                <a:solidFill>
-                  <a:srgbClr val="FFFFFF"/>
-                </a:solidFill>
-              </a:defRPr>
-            </a:pPr>
-            <a:r>
-              <a:t>System architecture</a:t>
-            </a:r>
-          </a:p>
-        </p:txBody>
-      </p:sp>
-      <p:sp>
-        <p:nvSpPr>
-          <p:cNvPr id="4" name="TextBox 3"/>
-          <p:cNvSpPr txBox="1"/>
-          <p:nvPr/>
-        </p:nvSpPr>
-        <p:spPr>
-          <a:xfrm>
-            <a:off x="9418320" y="384048"/>
-            <a:ext cx="2377440" cy="457200"/>
-          </a:xfrm>
-          <a:prstGeom prst="rect">
-            <a:avLst/>
-          </a:prstGeom>
-          <a:noFill/>
-        </p:spPr>
-        <p:txBody>
-          <a:bodyPr wrap="none">
-            <a:spAutoFit/>
-          </a:bodyPr>
-          <a:lstStyle/>
-          <a:p>
-            <a:pPr>
-              <a:defRPr sz="1400">
-                <a:solidFill>
-                  <a:srgbClr val="E09F1F"/>
-                </a:solidFill>
-              </a:defRPr>
-            </a:pPr>
-            <a:r>
-              <a:t>Technical deep dive</a:t>
-            </a:r>
-          </a:p>
-        </p:txBody>
-      </p:sp>
-      <p:sp>
-        <p:nvSpPr>
-          <p:cNvPr id="5" name="TextBox 4"/>
-          <p:cNvSpPr txBox="1"/>
-          <p:nvPr/>
-        </p:nvSpPr>
-        <p:spPr>
-          <a:xfrm>
-            <a:off x="548640" y="1463040"/>
-            <a:ext cx="11064240" cy="5029200"/>
-          </a:xfrm>
-          <a:prstGeom prst="rect">
-            <a:avLst/>
-          </a:prstGeom>
-          <a:noFill/>
-        </p:spPr>
-        <p:txBody>
-          <a:bodyPr wrap="square">
-            <a:spAutoFit/>
-          </a:bodyPr>
-          <a:lstStyle/>
-          <a:p>
-            <a:pPr>
-              <a:spcAft>
-                <a:spcPts val="1200"/>
-              </a:spcAft>
-              <a:defRPr sz="2000">
-                <a:solidFill>
-                  <a:srgbClr val="222222"/>
-                </a:solidFill>
-              </a:defRPr>
-            </a:pPr>
-            <a:r>
-              <a:t>•  src/data.py: download prices (Yahoo Finance), build 19 candidate features per stock per day, select features, define time-series splits.</a:t>
-            </a:r>
-          </a:p>
-          <a:p>
-            <a:pPr>
-              <a:spcAft>
-                <a:spcPts val="1200"/>
-              </a:spcAft>
-              <a:defRPr sz="2000">
-                <a:solidFill>
-                  <a:srgbClr val="222222"/>
-                </a:solidFill>
-              </a:defRPr>
-            </a:pPr>
-            <a:r>
-              <a:t>•  src/model.py: tune and cross-validate, train three LightGBM quantile models, evaluate on a hold-out period, compute SHAP, run a backtest, export data/artifacts.pkl and reports/metrics.json.</a:t>
-            </a:r>
-          </a:p>
-          <a:p>
-            <a:pPr>
-              <a:spcAft>
-                <a:spcPts val="1200"/>
-              </a:spcAft>
-              <a:defRPr sz="2000">
-                <a:solidFill>
-                  <a:srgbClr val="222222"/>
-                </a:solidFill>
-              </a:defRPr>
-            </a:pPr>
-            <a:r>
-              <a:t>•  src/portfolio_advisor/core.py: decision engine. Combines the technical score, fundamental score, model forecast and risk fit by profile weights, sizes positions with Hierarchical Risk Parity, a position cap and whole shares.</a:t>
-            </a:r>
-          </a:p>
-          <a:p>
-            <a:pPr>
-              <a:spcAft>
-                <a:spcPts val="1200"/>
-              </a:spcAft>
-              <a:defRPr sz="2000">
-                <a:solidFill>
-                  <a:srgbClr val="222222"/>
-                </a:solidFill>
-              </a:defRPr>
-            </a:pPr>
-            <a:r>
-              <a:t>•  app.py: Streamlit interface (profile intake, ranked book, stock research with SHAP, portfolio lab, validation, model report, live NSE quotes). api_app.py: optional FastAPI service.</a:t>
-            </a:r>
-          </a:p>
-          <a:p>
-            <a:pPr>
-              <a:spcAft>
-                <a:spcPts val="1200"/>
-              </a:spcAft>
-              <a:defRPr sz="2000">
-                <a:solidFill>
-                  <a:srgbClr val="222222"/>
-                </a:solidFill>
-              </a:defRPr>
-            </a:pPr>
-            <a:r>
-              <a:t>•  Flow: prices -&gt; features -&gt; selection -&gt; purged walk-forward CV -&gt; quantile models -&gt; artifact -&gt; app.</a:t>
-            </a:r>
-          </a:p>
-        </p:txBody>
-      </p:sp>
+      </p:pic>
     </p:spTree>
   </p:cSld>
   <p:clrMapOvr>
@@ -4569,232 +4185,30 @@
         <p:nvPr/>
       </p:nvGrpSpPr>
       <p:grpSpPr/>
-      <p:sp>
-        <p:nvSpPr>
-          <p:cNvPr id="2" name="Rectangle 1"/>
-          <p:cNvSpPr/>
+      <p:pic>
+        <p:nvPicPr>
+          <p:cNvPr id="2" name="Slide 5: Tuning beat the notebook by 9.2%, and only tied the naive baseline." descr="Tuning beat the notebook by 9.2%, and only tied the naive baseline. Validation: purged walk-forward cross-validation, 5 expanding folds. Each fold trains on the past and validates on the next block, with 31 trading days removed in between because each label looks 21 days ahead. Hold-out 2025-01-23 to 2026-09-09 (24,413 stock-days) never used for selection or tuning. Search: random search over 25 settings x 5 folds x 3 quantiles = 375 model fits, scored by mean pinball loss. CV pinball loss: naive baseline 0.02395; LightGBM notebook settings 0.02648; LightGBM tuned 0.02406 +/- 0.00529; Ridge is a point forecast with no quantiles (CV MAE 0.0731 vs naive 0.0722). Tuning improved on the notebook settings by 9.2%. Against the naive no-feature baseline the tuned model is 0.5% worse, inside fold-to-fold variation. Chosen settings: n_estimators=100, learning_rate=0.02, num_leaves=4, min_child_samples=50, subsample=0.8, colsample_bytree=0.5, reg_lambda=0. With a weak signal, complex trees fit noise."/>
+          <p:cNvPicPr>
+            <a:picLocks noChangeAspect="1"/>
+          </p:cNvPicPr>
           <p:nvPr/>
-        </p:nvSpPr>
+        </p:nvPicPr>
+        <p:blipFill>
+          <a:blip r:embed="rId2"/>
+          <a:stretch>
+            <a:fillRect/>
+          </a:stretch>
+        </p:blipFill>
         <p:spPr>
           <a:xfrm>
             <a:off x="0" y="0"/>
-            <a:ext cx="12191695" cy="1143000"/>
+            <a:ext cx="18288000" cy="10287000"/>
           </a:xfrm>
           <a:prstGeom prst="rect">
             <a:avLst/>
           </a:prstGeom>
-          <a:solidFill>
-            <a:srgbClr val="141B3C"/>
-          </a:solidFill>
-          <a:ln>
-            <a:noFill/>
-          </a:ln>
         </p:spPr>
-        <p:style>
-          <a:lnRef idx="1">
-            <a:schemeClr val="accent1"/>
-          </a:lnRef>
-          <a:fillRef idx="3">
-            <a:schemeClr val="accent1"/>
-          </a:fillRef>
-          <a:effectRef idx="2">
-            <a:schemeClr val="accent1"/>
-          </a:effectRef>
-          <a:fontRef idx="minor">
-            <a:schemeClr val="lt1"/>
-          </a:fontRef>
-        </p:style>
-        <p:txBody>
-          <a:bodyPr rtlCol="0" anchor="ctr"/>
-          <a:lstStyle/>
-          <a:p>
-            <a:pPr algn="ctr"/>
-          </a:p>
-        </p:txBody>
-      </p:sp>
-      <p:sp>
-        <p:nvSpPr>
-          <p:cNvPr id="3" name="TextBox 2"/>
-          <p:cNvSpPr txBox="1"/>
-          <p:nvPr/>
-        </p:nvSpPr>
-        <p:spPr>
-          <a:xfrm>
-            <a:off x="548640" y="256032"/>
-            <a:ext cx="10058400" cy="731520"/>
-          </a:xfrm>
-          <a:prstGeom prst="rect">
-            <a:avLst/>
-          </a:prstGeom>
-          <a:noFill/>
-        </p:spPr>
-        <p:txBody>
-          <a:bodyPr wrap="none">
-            <a:spAutoFit/>
-          </a:bodyPr>
-          <a:lstStyle/>
-          <a:p>
-            <a:pPr>
-              <a:defRPr sz="3000" b="1">
-                <a:solidFill>
-                  <a:srgbClr val="FFFFFF"/>
-                </a:solidFill>
-              </a:defRPr>
-            </a:pPr>
-            <a:r>
-              <a:t>Data and preprocessing</a:t>
-            </a:r>
-          </a:p>
-        </p:txBody>
-      </p:sp>
-      <p:sp>
-        <p:nvSpPr>
-          <p:cNvPr id="4" name="TextBox 3"/>
-          <p:cNvSpPr txBox="1"/>
-          <p:nvPr/>
-        </p:nvSpPr>
-        <p:spPr>
-          <a:xfrm>
-            <a:off x="9418320" y="384048"/>
-            <a:ext cx="2377440" cy="457200"/>
-          </a:xfrm>
-          <a:prstGeom prst="rect">
-            <a:avLst/>
-          </a:prstGeom>
-          <a:noFill/>
-        </p:spPr>
-        <p:txBody>
-          <a:bodyPr wrap="none">
-            <a:spAutoFit/>
-          </a:bodyPr>
-          <a:lstStyle/>
-          <a:p>
-            <a:pPr>
-              <a:defRPr sz="1400">
-                <a:solidFill>
-                  <a:srgbClr val="E09F1F"/>
-                </a:solidFill>
-              </a:defRPr>
-            </a:pPr>
-            <a:r>
-              <a:t>Technical deep dive</a:t>
-            </a:r>
-          </a:p>
-        </p:txBody>
-      </p:sp>
-      <p:sp>
-        <p:nvSpPr>
-          <p:cNvPr id="5" name="TextBox 4"/>
-          <p:cNvSpPr txBox="1"/>
-          <p:nvPr/>
-        </p:nvSpPr>
-        <p:spPr>
-          <a:xfrm>
-            <a:off x="548640" y="1463040"/>
-            <a:ext cx="11064240" cy="5029200"/>
-          </a:xfrm>
-          <a:prstGeom prst="rect">
-            <a:avLst/>
-          </a:prstGeom>
-          <a:noFill/>
-        </p:spPr>
-        <p:txBody>
-          <a:bodyPr wrap="square">
-            <a:spAutoFit/>
-          </a:bodyPr>
-          <a:lstStyle/>
-          <a:p>
-            <a:pPr>
-              <a:spcAft>
-                <a:spcPts val="1200"/>
-              </a:spcAft>
-              <a:defRPr sz="1700">
-                <a:solidFill>
-                  <a:srgbClr val="222222"/>
-                </a:solidFill>
-              </a:defRPr>
-            </a:pPr>
-            <a:r>
-              <a:t>•  60 liquid NSE large caps, five per sector across 12 sectors, daily adjusted prices 2018-02-19 to 2026-10-08: 118,641 stock-days.</a:t>
-            </a:r>
-          </a:p>
-          <a:p>
-            <a:pPr>
-              <a:spcAft>
-                <a:spcPts val="1200"/>
-              </a:spcAft>
-              <a:defRPr sz="1700">
-                <a:solidFill>
-                  <a:srgbClr val="222222"/>
-                </a:solidFill>
-              </a:defRPr>
-            </a:pPr>
-            <a:r>
-              <a:t>•  Label: return over the next 21 trading days.</a:t>
-            </a:r>
-          </a:p>
-          <a:p>
-            <a:pPr>
-              <a:spcAft>
-                <a:spcPts val="1200"/>
-              </a:spcAft>
-              <a:defRPr sz="1700">
-                <a:solidFill>
-                  <a:srgbClr val="222222"/>
-                </a:solidFill>
-              </a:defRPr>
-            </a:pPr>
-            <a:r>
-              <a:t>•  Features are returns, ratios and oscillators (RSI, MACD histogram scaled by price, Bollinger bandwidth, ATR, stochastic %K, OBV change, Williams %R, momentum, volatility, distance from 52-week high, volume surge, market-relative return, market return and volatility).</a:t>
-            </a:r>
-          </a:p>
-          <a:p>
-            <a:pPr>
-              <a:spcAft>
-                <a:spcPts val="1200"/>
-              </a:spcAft>
-              <a:defRPr sz="1700">
-                <a:solidFill>
-                  <a:srgbClr val="222222"/>
-                </a:solidFill>
-              </a:defRPr>
-            </a:pPr>
-            <a:r>
-              <a:t>•  Log price is fractionally differenced with the smallest order that passes the ADF test, chosen on development data only.</a:t>
-            </a:r>
-          </a:p>
-          <a:p>
-            <a:pPr>
-              <a:spcAft>
-                <a:spcPts val="1200"/>
-              </a:spcAft>
-              <a:defRPr sz="1700">
-                <a:solidFill>
-                  <a:srgbClr val="222222"/>
-                </a:solidFill>
-              </a:defRPr>
-            </a:pPr>
-            <a:r>
-              <a:t>•  StandardScaler inside the Ridge pipeline, refitted on each training fold. Tree models split on thresholds and are unaffected by feature scale, so LightGBM gets unscaled inputs.</a:t>
-            </a:r>
-          </a:p>
-          <a:p>
-            <a:pPr>
-              <a:spcAft>
-                <a:spcPts val="1200"/>
-              </a:spcAft>
-              <a:defRPr sz="1700">
-                <a:solidFill>
-                  <a:srgbClr val="222222"/>
-                </a:solidFill>
-              </a:defRPr>
-            </a:pPr>
-            <a:r>
-              <a:t>•  Rows missing any candidate feature (indicator warm-up) are dropped.</a:t>
-            </a:r>
-          </a:p>
-        </p:txBody>
-      </p:sp>
+      </p:pic>
     </p:spTree>
   </p:cSld>
   <p:clrMapOvr>
@@ -4813,202 +4227,30 @@
         <p:nvPr/>
       </p:nvGrpSpPr>
       <p:grpSpPr/>
-      <p:sp>
-        <p:nvSpPr>
-          <p:cNvPr id="2" name="Rectangle 1"/>
-          <p:cNvSpPr/>
+      <p:pic>
+        <p:nvPicPr>
+          <p:cNvPr id="2" name="Slide 6: Honest ranges. No market-beating picks." descr="Honest ranges. No market-beating picks. Hold-out period 2025-01-23 to 2026-09-09, 24,413 stock-days never used for selection or tuning. P10-P90 coverage 82.4% against an 80% target. Pinball loss: LightGBM 0.01880 vs naive 0.01915. Rank information coefficient +0.046, positive on 56% of 407 days. Direction right 51.0% of the time. Backtest on the hold-out (every 21 trading days hold the 5 highest median forecasts, equal weight, 20 bps cost; benchmark = all stocks equal weight): strategy -4.4% a year vs benchmark +3.3% a year, median over 21 start days; excess -6.4% (range -16.8% to +7.1%); beat the benchmark from 24% of start days. In cross-validation folds the excess was +1.6% a year (range -4.3% to +16.6%). SHAP (TreeExplainer on the median model), largest drivers: mkt_vol_21, mom_126_21, fracdiff_close, vol_63, ret_63. Error analysis: calm markets rank IC -0.079, normal +0.076, turbulent +0.142; direction right 31.1% when the market fell and 64.6% when it rose. Limits: 21-day returns are mostly noise; universe is 60 of today's large caps (survivorship bias) and one country; the backtest ignores taxes, market impact and slippage beyond a flat cost. Next: point-in-time fundamentals, a market-relative target, a larger universe including delisted names, a controlled paper-trading period."/>
+          <p:cNvPicPr>
+            <a:picLocks noChangeAspect="1"/>
+          </p:cNvPicPr>
           <p:nvPr/>
-        </p:nvSpPr>
+        </p:nvPicPr>
+        <p:blipFill>
+          <a:blip r:embed="rId2"/>
+          <a:stretch>
+            <a:fillRect/>
+          </a:stretch>
+        </p:blipFill>
         <p:spPr>
           <a:xfrm>
             <a:off x="0" y="0"/>
-            <a:ext cx="12191695" cy="1143000"/>
+            <a:ext cx="18288000" cy="10287000"/>
           </a:xfrm>
           <a:prstGeom prst="rect">
             <a:avLst/>
           </a:prstGeom>
-          <a:solidFill>
-            <a:srgbClr val="141B3C"/>
-          </a:solidFill>
-          <a:ln>
-            <a:noFill/>
-          </a:ln>
         </p:spPr>
-        <p:style>
-          <a:lnRef idx="1">
-            <a:schemeClr val="accent1"/>
-          </a:lnRef>
-          <a:fillRef idx="3">
-            <a:schemeClr val="accent1"/>
-          </a:fillRef>
-          <a:effectRef idx="2">
-            <a:schemeClr val="accent1"/>
-          </a:effectRef>
-          <a:fontRef idx="minor">
-            <a:schemeClr val="lt1"/>
-          </a:fontRef>
-        </p:style>
-        <p:txBody>
-          <a:bodyPr rtlCol="0" anchor="ctr"/>
-          <a:lstStyle/>
-          <a:p>
-            <a:pPr algn="ctr"/>
-          </a:p>
-        </p:txBody>
-      </p:sp>
-      <p:sp>
-        <p:nvSpPr>
-          <p:cNvPr id="3" name="TextBox 2"/>
-          <p:cNvSpPr txBox="1"/>
-          <p:nvPr/>
-        </p:nvSpPr>
-        <p:spPr>
-          <a:xfrm>
-            <a:off x="548640" y="256032"/>
-            <a:ext cx="10058400" cy="731520"/>
-          </a:xfrm>
-          <a:prstGeom prst="rect">
-            <a:avLst/>
-          </a:prstGeom>
-          <a:noFill/>
-        </p:spPr>
-        <p:txBody>
-          <a:bodyPr wrap="none">
-            <a:spAutoFit/>
-          </a:bodyPr>
-          <a:lstStyle/>
-          <a:p>
-            <a:pPr>
-              <a:defRPr sz="3000" b="1">
-                <a:solidFill>
-                  <a:srgbClr val="FFFFFF"/>
-                </a:solidFill>
-              </a:defRPr>
-            </a:pPr>
-            <a:r>
-              <a:t>Feature selection</a:t>
-            </a:r>
-          </a:p>
-        </p:txBody>
-      </p:sp>
-      <p:sp>
-        <p:nvSpPr>
-          <p:cNvPr id="4" name="TextBox 3"/>
-          <p:cNvSpPr txBox="1"/>
-          <p:nvPr/>
-        </p:nvSpPr>
-        <p:spPr>
-          <a:xfrm>
-            <a:off x="9418320" y="384048"/>
-            <a:ext cx="2377440" cy="457200"/>
-          </a:xfrm>
-          <a:prstGeom prst="rect">
-            <a:avLst/>
-          </a:prstGeom>
-          <a:noFill/>
-        </p:spPr>
-        <p:txBody>
-          <a:bodyPr wrap="none">
-            <a:spAutoFit/>
-          </a:bodyPr>
-          <a:lstStyle/>
-          <a:p>
-            <a:pPr>
-              <a:defRPr sz="1400">
-                <a:solidFill>
-                  <a:srgbClr val="E09F1F"/>
-                </a:solidFill>
-              </a:defRPr>
-            </a:pPr>
-            <a:r>
-              <a:t>Technical deep dive</a:t>
-            </a:r>
-          </a:p>
-        </p:txBody>
-      </p:sp>
-      <p:sp>
-        <p:nvSpPr>
-          <p:cNvPr id="5" name="TextBox 4"/>
-          <p:cNvSpPr txBox="1"/>
-          <p:nvPr/>
-        </p:nvSpPr>
-        <p:spPr>
-          <a:xfrm>
-            <a:off x="548640" y="1463040"/>
-            <a:ext cx="11064240" cy="5029200"/>
-          </a:xfrm>
-          <a:prstGeom prst="rect">
-            <a:avLst/>
-          </a:prstGeom>
-          <a:noFill/>
-        </p:spPr>
-        <p:txBody>
-          <a:bodyPr wrap="square">
-            <a:spAutoFit/>
-          </a:bodyPr>
-          <a:lstStyle/>
-          <a:p>
-            <a:pPr>
-              <a:spcAft>
-                <a:spcPts val="1200"/>
-              </a:spcAft>
-              <a:defRPr sz="2000">
-                <a:solidFill>
-                  <a:srgbClr val="222222"/>
-                </a:solidFill>
-              </a:defRPr>
-            </a:pPr>
-            <a:r>
-              <a:t>•  Method: greedy mutual-information relevance minus 0.5 x redundancy, run on development data only.</a:t>
-            </a:r>
-          </a:p>
-          <a:p>
-            <a:pPr>
-              <a:spcAft>
-                <a:spcPts val="1200"/>
-              </a:spcAft>
-              <a:defRPr sz="2000">
-                <a:solidFill>
-                  <a:srgbClr val="222222"/>
-                </a:solidFill>
-              </a:defRPr>
-            </a:pPr>
-            <a:r>
-              <a:t>•  Kept 10 of 19: mkt_vol_21, fracdiff_close, rel_ret_21, volume_surge, mom_126_21, Stoch_K, vol_63, ret_63, OBV_delta, Boll_BW.</a:t>
-            </a:r>
-          </a:p>
-          <a:p>
-            <a:pPr>
-              <a:spcAft>
-                <a:spcPts val="1200"/>
-              </a:spcAft>
-              <a:defRPr sz="2000">
-                <a:solidFill>
-                  <a:srgbClr val="222222"/>
-                </a:solidFill>
-              </a:defRPr>
-            </a:pPr>
-            <a:r>
-              <a:t>•  Why: many indicators measure the same thing (RSI, stochastic %K and Williams %R all track short-term position in the range). The redundancy penalty keeps one of each kind.</a:t>
-            </a:r>
-          </a:p>
-          <a:p>
-            <a:pPr>
-              <a:spcAft>
-                <a:spcPts val="1200"/>
-              </a:spcAft>
-              <a:defRPr sz="2000">
-                <a:solidFill>
-                  <a:srgbClr val="222222"/>
-                </a:solidFill>
-              </a:defRPr>
-            </a:pPr>
-            <a:r>
-              <a:t>•  Company fundamentals were removed from the model. Only today's ratios are available, so using them on past dates would leak future information. They still feed the app's separate fundamental score.</a:t>
-            </a:r>
-          </a:p>
-        </p:txBody>
-      </p:sp>
+      </p:pic>
     </p:spTree>
   </p:cSld>
   <p:clrMapOvr>
@@ -5027,735 +4269,30 @@
         <p:nvPr/>
       </p:nvGrpSpPr>
       <p:grpSpPr/>
-      <p:sp>
-        <p:nvSpPr>
-          <p:cNvPr id="2" name="Rectangle 1"/>
-          <p:cNvSpPr/>
+      <p:pic>
+        <p:nvPicPr>
+          <p:cNvPr id="2" name="Slide 7: Live demo" descr="Live demo Live demo steps: profile intake, ranked book, stock research with SHAP, portfolio lab, model report. Live app https://fn.iimbg.com . Landing page https://fin.iimbg.com . Code https://github.com/build-with-bala/ai-portfolio-advisor . Engineering: built with Claude Code and verified by the team; 22 automated tests; one command (python -m src.model) retrains from the committed data snapshot in about a minute; prompts, failures and fixes are in docs/VIBE_CODING_LOG.md. Team: Group 5: B Gokul Vaigundh (DBM/1015/03), Balaji G (DBM/1016/03), Shashaanth NC (DBM/1070/03)."/>
+          <p:cNvPicPr>
+            <a:picLocks noChangeAspect="1"/>
+          </p:cNvPicPr>
           <p:nvPr/>
-        </p:nvSpPr>
+        </p:nvPicPr>
+        <p:blipFill>
+          <a:blip r:embed="rId2"/>
+          <a:stretch>
+            <a:fillRect/>
+          </a:stretch>
+        </p:blipFill>
         <p:spPr>
           <a:xfrm>
             <a:off x="0" y="0"/>
-            <a:ext cx="12191695" cy="1143000"/>
+            <a:ext cx="18288000" cy="10287000"/>
           </a:xfrm>
           <a:prstGeom prst="rect">
             <a:avLst/>
           </a:prstGeom>
-          <a:solidFill>
-            <a:srgbClr val="141B3C"/>
-          </a:solidFill>
-          <a:ln>
-            <a:noFill/>
-          </a:ln>
         </p:spPr>
-        <p:style>
-          <a:lnRef idx="1">
-            <a:schemeClr val="accent1"/>
-          </a:lnRef>
-          <a:fillRef idx="3">
-            <a:schemeClr val="accent1"/>
-          </a:fillRef>
-          <a:effectRef idx="2">
-            <a:schemeClr val="accent1"/>
-          </a:effectRef>
-          <a:fontRef idx="minor">
-            <a:schemeClr val="lt1"/>
-          </a:fontRef>
-        </p:style>
-        <p:txBody>
-          <a:bodyPr rtlCol="0" anchor="ctr"/>
-          <a:lstStyle/>
-          <a:p>
-            <a:pPr algn="ctr"/>
-          </a:p>
-        </p:txBody>
-      </p:sp>
-      <p:sp>
-        <p:nvSpPr>
-          <p:cNvPr id="3" name="TextBox 2"/>
-          <p:cNvSpPr txBox="1"/>
-          <p:nvPr/>
-        </p:nvSpPr>
-        <p:spPr>
-          <a:xfrm>
-            <a:off x="548640" y="256032"/>
-            <a:ext cx="10058400" cy="731520"/>
-          </a:xfrm>
-          <a:prstGeom prst="rect">
-            <a:avLst/>
-          </a:prstGeom>
-          <a:noFill/>
-        </p:spPr>
-        <p:txBody>
-          <a:bodyPr wrap="none">
-            <a:spAutoFit/>
-          </a:bodyPr>
-          <a:lstStyle/>
-          <a:p>
-            <a:pPr>
-              <a:defRPr sz="3000" b="1">
-                <a:solidFill>
-                  <a:srgbClr val="FFFFFF"/>
-                </a:solidFill>
-              </a:defRPr>
-            </a:pPr>
-            <a:r>
-              <a:t>Tuning and cross-validation</a:t>
-            </a:r>
-          </a:p>
-        </p:txBody>
-      </p:sp>
-      <p:sp>
-        <p:nvSpPr>
-          <p:cNvPr id="4" name="TextBox 3"/>
-          <p:cNvSpPr txBox="1"/>
-          <p:nvPr/>
-        </p:nvSpPr>
-        <p:spPr>
-          <a:xfrm>
-            <a:off x="9418320" y="384048"/>
-            <a:ext cx="2377440" cy="457200"/>
-          </a:xfrm>
-          <a:prstGeom prst="rect">
-            <a:avLst/>
-          </a:prstGeom>
-          <a:noFill/>
-        </p:spPr>
-        <p:txBody>
-          <a:bodyPr wrap="none">
-            <a:spAutoFit/>
-          </a:bodyPr>
-          <a:lstStyle/>
-          <a:p>
-            <a:pPr>
-              <a:defRPr sz="1400">
-                <a:solidFill>
-                  <a:srgbClr val="E09F1F"/>
-                </a:solidFill>
-              </a:defRPr>
-            </a:pPr>
-            <a:r>
-              <a:t>Technical deep dive</a:t>
-            </a:r>
-          </a:p>
-        </p:txBody>
-      </p:sp>
-      <p:sp>
-        <p:nvSpPr>
-          <p:cNvPr id="5" name="TextBox 4"/>
-          <p:cNvSpPr txBox="1"/>
-          <p:nvPr/>
-        </p:nvSpPr>
-        <p:spPr>
-          <a:xfrm>
-            <a:off x="548640" y="1463040"/>
-            <a:ext cx="11064240" cy="5029200"/>
-          </a:xfrm>
-          <a:prstGeom prst="rect">
-            <a:avLst/>
-          </a:prstGeom>
-          <a:noFill/>
-        </p:spPr>
-        <p:txBody>
-          <a:bodyPr wrap="square">
-            <a:spAutoFit/>
-          </a:bodyPr>
-          <a:lstStyle/>
-          <a:p>
-            <a:pPr>
-              <a:spcAft>
-                <a:spcPts val="1200"/>
-              </a:spcAft>
-              <a:defRPr sz="1700">
-                <a:solidFill>
-                  <a:srgbClr val="222222"/>
-                </a:solidFill>
-              </a:defRPr>
-            </a:pPr>
-            <a:r>
-              <a:t>•  Scheme: purged walk-forward cross-validation, 5 expanding folds. Each fold trains on the past and validates on the next block, with 31 trading days removed in between because each label looks 21 days ahead.</a:t>
-            </a:r>
-          </a:p>
-          <a:p>
-            <a:pPr>
-              <a:spcAft>
-                <a:spcPts val="1200"/>
-              </a:spcAft>
-              <a:defRPr sz="1700">
-                <a:solidFill>
-                  <a:srgbClr val="222222"/>
-                </a:solidFill>
-              </a:defRPr>
-            </a:pPr>
-            <a:r>
-              <a:t>•  Search: random search over 25 settings x 5 folds x 3 quantiles = 375 model fits. Tuning metric: mean pinball loss (the loss a quantile forecast is meant to minimise).</a:t>
-            </a:r>
-          </a:p>
-          <a:p>
-            <a:pPr>
-              <a:spcAft>
-                <a:spcPts val="1200"/>
-              </a:spcAft>
-              <a:defRPr sz="1700">
-                <a:solidFill>
-                  <a:srgbClr val="222222"/>
-                </a:solidFill>
-              </a:defRPr>
-            </a:pPr>
-            <a:r>
-              <a:t>•  Chosen settings: n_estimators=100, learning_rate=0.02, num_leaves=4, min_child_samples=50, subsample=0.8, colsample_bytree=0.5, reg_lambda=0.</a:t>
-            </a:r>
-          </a:p>
-          <a:p>
-            <a:pPr>
-              <a:spcAft>
-                <a:spcPts val="1200"/>
-              </a:spcAft>
-              <a:defRPr sz="1700">
-                <a:solidFill>
-                  <a:srgbClr val="222222"/>
-                </a:solidFill>
-              </a:defRPr>
-            </a:pPr>
-            <a:r>
-              <a:t>•  CV pinball loss: tuned 0.02406 +/- 0.00529; notebook settings 0.02648; naive baseline 0.02395.</a:t>
-            </a:r>
-          </a:p>
-          <a:p>
-            <a:pPr>
-              <a:spcAft>
-                <a:spcPts val="1200"/>
-              </a:spcAft>
-              <a:defRPr sz="1700">
-                <a:solidFill>
-                  <a:srgbClr val="222222"/>
-                </a:solidFill>
-              </a:defRPr>
-            </a:pPr>
-            <a:r>
-              <a:t>•  Tuning improved on the original notebook settings by 9.2%. The search picked very small trees (4 leaves, 100 trees): with a weak signal, complex trees fit noise.</a:t>
-            </a:r>
-          </a:p>
-          <a:p>
-            <a:pPr>
-              <a:spcAft>
-                <a:spcPts val="1200"/>
-              </a:spcAft>
-              <a:defRPr sz="1700">
-                <a:solidFill>
-                  <a:srgbClr val="222222"/>
-                </a:solidFill>
-              </a:defRPr>
-            </a:pPr>
-            <a:r>
-              <a:t>•  Against the naive no-feature baseline the tuned model is 0.5% worse in cross-validation, which is inside fold-to-fold variation. We report this as it is.</a:t>
-            </a:r>
-          </a:p>
-        </p:txBody>
-      </p:sp>
-    </p:spTree>
-  </p:cSld>
-  <p:clrMapOvr>
-    <a:masterClrMapping/>
-  </p:clrMapOvr>
-</p:sld>
-</file>
-
-<file path=ppt/slides/slide8.xml><?xml version="1.0" encoding="utf-8"?>
-<p:sld xmlns:a="http://schemas.openxmlformats.org/drawingml/2006/main" xmlns:p="http://schemas.openxmlformats.org/presentationml/2006/main" xmlns:r="http://schemas.openxmlformats.org/officeDocument/2006/relationships">
-  <p:cSld>
-    <p:spTree>
-      <p:nvGrpSpPr>
-        <p:cNvPr id="1" name=""/>
-        <p:cNvGrpSpPr/>
-        <p:nvPr/>
-      </p:nvGrpSpPr>
-      <p:grpSpPr/>
-      <p:sp>
-        <p:nvSpPr>
-          <p:cNvPr id="2" name="Rectangle 1"/>
-          <p:cNvSpPr/>
-          <p:nvPr/>
-        </p:nvSpPr>
-        <p:spPr>
-          <a:xfrm>
-            <a:off x="0" y="0"/>
-            <a:ext cx="12191695" cy="1143000"/>
-          </a:xfrm>
-          <a:prstGeom prst="rect">
-            <a:avLst/>
-          </a:prstGeom>
-          <a:solidFill>
-            <a:srgbClr val="141B3C"/>
-          </a:solidFill>
-          <a:ln>
-            <a:noFill/>
-          </a:ln>
-        </p:spPr>
-        <p:style>
-          <a:lnRef idx="1">
-            <a:schemeClr val="accent1"/>
-          </a:lnRef>
-          <a:fillRef idx="3">
-            <a:schemeClr val="accent1"/>
-          </a:fillRef>
-          <a:effectRef idx="2">
-            <a:schemeClr val="accent1"/>
-          </a:effectRef>
-          <a:fontRef idx="minor">
-            <a:schemeClr val="lt1"/>
-          </a:fontRef>
-        </p:style>
-        <p:txBody>
-          <a:bodyPr rtlCol="0" anchor="ctr"/>
-          <a:lstStyle/>
-          <a:p>
-            <a:pPr algn="ctr"/>
-          </a:p>
-        </p:txBody>
-      </p:sp>
-      <p:sp>
-        <p:nvSpPr>
-          <p:cNvPr id="3" name="TextBox 2"/>
-          <p:cNvSpPr txBox="1"/>
-          <p:nvPr/>
-        </p:nvSpPr>
-        <p:spPr>
-          <a:xfrm>
-            <a:off x="548640" y="256032"/>
-            <a:ext cx="10058400" cy="731520"/>
-          </a:xfrm>
-          <a:prstGeom prst="rect">
-            <a:avLst/>
-          </a:prstGeom>
-          <a:noFill/>
-        </p:spPr>
-        <p:txBody>
-          <a:bodyPr wrap="none">
-            <a:spAutoFit/>
-          </a:bodyPr>
-          <a:lstStyle/>
-          <a:p>
-            <a:pPr>
-              <a:defRPr sz="3000" b="1">
-                <a:solidFill>
-                  <a:srgbClr val="FFFFFF"/>
-                </a:solidFill>
-              </a:defRPr>
-            </a:pPr>
-            <a:r>
-              <a:t>Hold-out results</a:t>
-            </a:r>
-          </a:p>
-        </p:txBody>
-      </p:sp>
-      <p:sp>
-        <p:nvSpPr>
-          <p:cNvPr id="4" name="TextBox 3"/>
-          <p:cNvSpPr txBox="1"/>
-          <p:nvPr/>
-        </p:nvSpPr>
-        <p:spPr>
-          <a:xfrm>
-            <a:off x="9418320" y="384048"/>
-            <a:ext cx="2377440" cy="457200"/>
-          </a:xfrm>
-          <a:prstGeom prst="rect">
-            <a:avLst/>
-          </a:prstGeom>
-          <a:noFill/>
-        </p:spPr>
-        <p:txBody>
-          <a:bodyPr wrap="none">
-            <a:spAutoFit/>
-          </a:bodyPr>
-          <a:lstStyle/>
-          <a:p>
-            <a:pPr>
-              <a:defRPr sz="1400">
-                <a:solidFill>
-                  <a:srgbClr val="E09F1F"/>
-                </a:solidFill>
-              </a:defRPr>
-            </a:pPr>
-            <a:r>
-              <a:t>Technical deep dive</a:t>
-            </a:r>
-          </a:p>
-        </p:txBody>
-      </p:sp>
-      <p:sp>
-        <p:nvSpPr>
-          <p:cNvPr id="5" name="TextBox 4"/>
-          <p:cNvSpPr txBox="1"/>
-          <p:nvPr/>
-        </p:nvSpPr>
-        <p:spPr>
-          <a:xfrm>
-            <a:off x="548640" y="1463040"/>
-            <a:ext cx="11064240" cy="5029200"/>
-          </a:xfrm>
-          <a:prstGeom prst="rect">
-            <a:avLst/>
-          </a:prstGeom>
-          <a:noFill/>
-        </p:spPr>
-        <p:txBody>
-          <a:bodyPr wrap="square">
-            <a:spAutoFit/>
-          </a:bodyPr>
-          <a:lstStyle/>
-          <a:p>
-            <a:pPr>
-              <a:spcAft>
-                <a:spcPts val="1200"/>
-              </a:spcAft>
-              <a:defRPr sz="1700">
-                <a:solidFill>
-                  <a:srgbClr val="222222"/>
-                </a:solidFill>
-              </a:defRPr>
-            </a:pPr>
-            <a:r>
-              <a:t>•  Hold-out period: 2025-01-23 to 2026-09-09, 24,413 stock-days never used for selection or tuning.</a:t>
-            </a:r>
-          </a:p>
-          <a:p>
-            <a:pPr>
-              <a:spcAft>
-                <a:spcPts val="1200"/>
-              </a:spcAft>
-              <a:defRPr sz="1700">
-                <a:solidFill>
-                  <a:srgbClr val="222222"/>
-                </a:solidFill>
-              </a:defRPr>
-            </a:pPr>
-            <a:r>
-              <a:t>•  Pinball loss: LightGBM 0.01880 vs naive 0.01915. MAE: LightGBM 0.0583, Ridge 0.0580, naive 0.0584.</a:t>
-            </a:r>
-          </a:p>
-          <a:p>
-            <a:pPr>
-              <a:spcAft>
-                <a:spcPts val="1200"/>
-              </a:spcAft>
-              <a:defRPr sz="1700">
-                <a:solidFill>
-                  <a:srgbClr val="222222"/>
-                </a:solidFill>
-              </a:defRPr>
-            </a:pPr>
-            <a:r>
-              <a:t>•  Rank information coefficient (daily rank correlation of forecast and outcome): LightGBM +0.046, positive on 56% of 407 days; Ridge +0.052.</a:t>
-            </a:r>
-          </a:p>
-          <a:p>
-            <a:pPr>
-              <a:spcAft>
-                <a:spcPts val="1200"/>
-              </a:spcAft>
-              <a:defRPr sz="1700">
-                <a:solidFill>
-                  <a:srgbClr val="222222"/>
-                </a:solidFill>
-              </a:defRPr>
-            </a:pPr>
-            <a:r>
-              <a:t>•  Direction right 51.0% of the time. P10-P90 coverage 82.4% against a 80% target.</a:t>
-            </a:r>
-          </a:p>
-          <a:p>
-            <a:pPr>
-              <a:spcAft>
-                <a:spcPts val="1200"/>
-              </a:spcAft>
-              <a:defRPr sz="1700">
-                <a:solidFill>
-                  <a:srgbClr val="222222"/>
-                </a:solidFill>
-              </a:defRPr>
-            </a:pPr>
-            <a:r>
-              <a:t>•  Backtest, hold-out: strategy -4.4%/yr vs benchmark 3.3%/yr; excess -6.4% (range -16.8% to 7.1%); beat the benchmark from 24% of start days.</a:t>
-            </a:r>
-          </a:p>
-          <a:p>
-            <a:pPr>
-              <a:spcAft>
-                <a:spcPts val="1200"/>
-              </a:spcAft>
-              <a:defRPr sz="1700">
-                <a:solidFill>
-                  <a:srgbClr val="222222"/>
-                </a:solidFill>
-              </a:defRPr>
-            </a:pPr>
-            <a:r>
-              <a:t>•  Backtest, cross-validation folds: excess 1.6%/yr (range -4.3% to 16.6%).</a:t>
-            </a:r>
-          </a:p>
-        </p:txBody>
-      </p:sp>
-    </p:spTree>
-  </p:cSld>
-  <p:clrMapOvr>
-    <a:masterClrMapping/>
-  </p:clrMapOvr>
-</p:sld>
-</file>
-
-<file path=ppt/slides/slide9.xml><?xml version="1.0" encoding="utf-8"?>
-<p:sld xmlns:a="http://schemas.openxmlformats.org/drawingml/2006/main" xmlns:p="http://schemas.openxmlformats.org/presentationml/2006/main" xmlns:r="http://schemas.openxmlformats.org/officeDocument/2006/relationships">
-  <p:cSld>
-    <p:spTree>
-      <p:nvGrpSpPr>
-        <p:cNvPr id="1" name=""/>
-        <p:cNvGrpSpPr/>
-        <p:nvPr/>
-      </p:nvGrpSpPr>
-      <p:grpSpPr/>
-      <p:sp>
-        <p:nvSpPr>
-          <p:cNvPr id="2" name="Rectangle 1"/>
-          <p:cNvSpPr/>
-          <p:nvPr/>
-        </p:nvSpPr>
-        <p:spPr>
-          <a:xfrm>
-            <a:off x="0" y="0"/>
-            <a:ext cx="12191695" cy="1143000"/>
-          </a:xfrm>
-          <a:prstGeom prst="rect">
-            <a:avLst/>
-          </a:prstGeom>
-          <a:solidFill>
-            <a:srgbClr val="141B3C"/>
-          </a:solidFill>
-          <a:ln>
-            <a:noFill/>
-          </a:ln>
-        </p:spPr>
-        <p:style>
-          <a:lnRef idx="1">
-            <a:schemeClr val="accent1"/>
-          </a:lnRef>
-          <a:fillRef idx="3">
-            <a:schemeClr val="accent1"/>
-          </a:fillRef>
-          <a:effectRef idx="2">
-            <a:schemeClr val="accent1"/>
-          </a:effectRef>
-          <a:fontRef idx="minor">
-            <a:schemeClr val="lt1"/>
-          </a:fontRef>
-        </p:style>
-        <p:txBody>
-          <a:bodyPr rtlCol="0" anchor="ctr"/>
-          <a:lstStyle/>
-          <a:p>
-            <a:pPr algn="ctr"/>
-          </a:p>
-        </p:txBody>
-      </p:sp>
-      <p:sp>
-        <p:nvSpPr>
-          <p:cNvPr id="3" name="TextBox 2"/>
-          <p:cNvSpPr txBox="1"/>
-          <p:nvPr/>
-        </p:nvSpPr>
-        <p:spPr>
-          <a:xfrm>
-            <a:off x="548640" y="256032"/>
-            <a:ext cx="10058400" cy="731520"/>
-          </a:xfrm>
-          <a:prstGeom prst="rect">
-            <a:avLst/>
-          </a:prstGeom>
-          <a:noFill/>
-        </p:spPr>
-        <p:txBody>
-          <a:bodyPr wrap="none">
-            <a:spAutoFit/>
-          </a:bodyPr>
-          <a:lstStyle/>
-          <a:p>
-            <a:pPr>
-              <a:defRPr sz="3000" b="1">
-                <a:solidFill>
-                  <a:srgbClr val="FFFFFF"/>
-                </a:solidFill>
-              </a:defRPr>
-            </a:pPr>
-            <a:r>
-              <a:t>Explainability and error analysis</a:t>
-            </a:r>
-          </a:p>
-        </p:txBody>
-      </p:sp>
-      <p:sp>
-        <p:nvSpPr>
-          <p:cNvPr id="4" name="TextBox 3"/>
-          <p:cNvSpPr txBox="1"/>
-          <p:nvPr/>
-        </p:nvSpPr>
-        <p:spPr>
-          <a:xfrm>
-            <a:off x="9418320" y="384048"/>
-            <a:ext cx="2377440" cy="457200"/>
-          </a:xfrm>
-          <a:prstGeom prst="rect">
-            <a:avLst/>
-          </a:prstGeom>
-          <a:noFill/>
-        </p:spPr>
-        <p:txBody>
-          <a:bodyPr wrap="none">
-            <a:spAutoFit/>
-          </a:bodyPr>
-          <a:lstStyle/>
-          <a:p>
-            <a:pPr>
-              <a:defRPr sz="1400">
-                <a:solidFill>
-                  <a:srgbClr val="E09F1F"/>
-                </a:solidFill>
-              </a:defRPr>
-            </a:pPr>
-            <a:r>
-              <a:t>Technical deep dive</a:t>
-            </a:r>
-          </a:p>
-        </p:txBody>
-      </p:sp>
-      <p:sp>
-        <p:nvSpPr>
-          <p:cNvPr id="5" name="TextBox 4"/>
-          <p:cNvSpPr txBox="1"/>
-          <p:nvPr/>
-        </p:nvSpPr>
-        <p:spPr>
-          <a:xfrm>
-            <a:off x="548640" y="1463040"/>
-            <a:ext cx="11064240" cy="5029200"/>
-          </a:xfrm>
-          <a:prstGeom prst="rect">
-            <a:avLst/>
-          </a:prstGeom>
-          <a:noFill/>
-        </p:spPr>
-        <p:txBody>
-          <a:bodyPr wrap="square">
-            <a:spAutoFit/>
-          </a:bodyPr>
-          <a:lstStyle/>
-          <a:p>
-            <a:pPr>
-              <a:spcAft>
-                <a:spcPts val="1200"/>
-              </a:spcAft>
-              <a:defRPr sz="1700">
-                <a:solidFill>
-                  <a:srgbClr val="222222"/>
-                </a:solidFill>
-              </a:defRPr>
-            </a:pPr>
-            <a:r>
-              <a:t>•  SHAP (TreeExplainer on the median model). Largest drivers: mkt_vol_21, mom_126_21, fracdiff_close, vol_63.</a:t>
-            </a:r>
-          </a:p>
-          <a:p>
-            <a:pPr>
-              <a:spcAft>
-                <a:spcPts val="1200"/>
-              </a:spcAft>
-              <a:defRPr sz="1700">
-                <a:solidFill>
-                  <a:srgbClr val="222222"/>
-                </a:solidFill>
-              </a:defRPr>
-            </a:pPr>
-            <a:r>
-              <a:t>•  Every stock page in the app shows that stock's own SHAP drivers for the current forecast.</a:t>
-            </a:r>
-          </a:p>
-          <a:p>
-            <a:pPr>
-              <a:spcAft>
-                <a:spcPts val="1200"/>
-              </a:spcAft>
-              <a:defRPr sz="1700">
-                <a:solidFill>
-                  <a:srgbClr val="222222"/>
-                </a:solidFill>
-              </a:defRPr>
-            </a:pPr>
-            <a:r>
-              <a:t>•  Calm markets: MAE 0.0517, coverage 82.4%, rank IC -0.079.</a:t>
-            </a:r>
-          </a:p>
-          <a:p>
-            <a:pPr>
-              <a:spcAft>
-                <a:spcPts val="1200"/>
-              </a:spcAft>
-              <a:defRPr sz="1700">
-                <a:solidFill>
-                  <a:srgbClr val="222222"/>
-                </a:solidFill>
-              </a:defRPr>
-            </a:pPr>
-            <a:r>
-              <a:t>•  Normal markets: MAE 0.0552, coverage 85.0%, rank IC +0.076.</a:t>
-            </a:r>
-          </a:p>
-          <a:p>
-            <a:pPr>
-              <a:spcAft>
-                <a:spcPts val="1200"/>
-              </a:spcAft>
-              <a:defRPr sz="1700">
-                <a:solidFill>
-                  <a:srgbClr val="222222"/>
-                </a:solidFill>
-              </a:defRPr>
-            </a:pPr>
-            <a:r>
-              <a:t>•  Turbulent markets: MAE 0.0680, coverage 79.8%, rank IC +0.142.</a:t>
-            </a:r>
-          </a:p>
-          <a:p>
-            <a:pPr>
-              <a:spcAft>
-                <a:spcPts val="1200"/>
-              </a:spcAft>
-              <a:defRPr sz="1700">
-                <a:solidFill>
-                  <a:srgbClr val="222222"/>
-                </a:solidFill>
-              </a:defRPr>
-            </a:pPr>
-            <a:r>
-              <a:t>•  When the market fell: MAE 0.0661, direction right 31.1%.</a:t>
-            </a:r>
-          </a:p>
-          <a:p>
-            <a:pPr>
-              <a:spcAft>
-                <a:spcPts val="1200"/>
-              </a:spcAft>
-              <a:defRPr sz="1700">
-                <a:solidFill>
-                  <a:srgbClr val="222222"/>
-                </a:solidFill>
-              </a:defRPr>
-            </a:pPr>
-            <a:r>
-              <a:t>•  When the market rose: MAE 0.0529, direction right 64.6%.</a:t>
-            </a:r>
-          </a:p>
-        </p:txBody>
-      </p:sp>
+      </p:pic>
     </p:spTree>
   </p:cSld>
   <p:clrMapOvr>
@@ -6082,4 +4619,324 @@
   </a:objectDefaults>
   <a:extraClrSchemeLst/>
 </a:theme>
+</file>
+
+<file path=ppt/theme/theme2.xml><?xml version="1.0" encoding="utf-8"?>
+<a:theme xmlns:a="http://schemas.openxmlformats.org/drawingml/2006/main" name="Office Theme">
+  <a:themeElements>
+    <a:clrScheme name="Office">
+      <a:dk1>
+        <a:sysClr val="windowText" lastClr="000000"/>
+      </a:dk1>
+      <a:lt1>
+        <a:sysClr val="window" lastClr="FFFFFF"/>
+      </a:lt1>
+      <a:dk2>
+        <a:srgbClr val="1F497D"/>
+      </a:dk2>
+      <a:lt2>
+        <a:srgbClr val="EEECE1"/>
+      </a:lt2>
+      <a:accent1>
+        <a:srgbClr val="4F81BD"/>
+      </a:accent1>
+      <a:accent2>
+        <a:srgbClr val="C0504D"/>
+      </a:accent2>
+      <a:accent3>
+        <a:srgbClr val="9BBB59"/>
+      </a:accent3>
+      <a:accent4>
+        <a:srgbClr val="8064A2"/>
+      </a:accent4>
+      <a:accent5>
+        <a:srgbClr val="4BACC6"/>
+      </a:accent5>
+      <a:accent6>
+        <a:srgbClr val="F79646"/>
+      </a:accent6>
+      <a:hlink>
+        <a:srgbClr val="0000FF"/>
+      </a:hlink>
+      <a:folHlink>
+        <a:srgbClr val="800080"/>
+      </a:folHlink>
+    </a:clrScheme>
+    <a:fontScheme name="Office">
+      <a:majorFont>
+        <a:latin typeface="Calibri"/>
+        <a:ea typeface=""/>
+        <a:cs typeface=""/>
+        <a:font script="Jpan" typeface="ＭＳ Ｐゴシック"/>
+        <a:font script="Hang" typeface="맑은 고딕"/>
+        <a:font script="Hans" typeface="宋体"/>
+        <a:font script="Hant" typeface="新細明體"/>
+        <a:font script="Arab" typeface="Times New Roman"/>
+        <a:font script="Hebr" typeface="Times New Roman"/>
+        <a:font script="Thai" typeface="Angsana New"/>
+        <a:font script="Ethi" typeface="Nyala"/>
+        <a:font script="Beng" typeface="Vrinda"/>
+        <a:font script="Gujr" typeface="Shruti"/>
+        <a:font script="Khmr" typeface="MoolBoran"/>
+        <a:font script="Knda" typeface="Tunga"/>
+        <a:font script="Guru" typeface="Raavi"/>
+        <a:font script="Cans" typeface="Euphemia"/>
+        <a:font script="Cher" typeface="Plantagenet Cherokee"/>
+        <a:font script="Yiii" typeface="Microsoft Yi Baiti"/>
+        <a:font script="Tibt" typeface="Microsoft Himalaya"/>
+        <a:font script="Thaa" typeface="MV Boli"/>
+        <a:font script="Deva" typeface="Mangal"/>
+        <a:font script="Telu" typeface="Gautami"/>
+        <a:font script="Taml" typeface="Latha"/>
+        <a:font script="Syrc" typeface="Estrangelo Edessa"/>
+        <a:font script="Orya" typeface="Kalinga"/>
+        <a:font script="Mlym" typeface="Kartika"/>
+        <a:font script="Laoo" typeface="DokChampa"/>
+        <a:font script="Sinh" typeface="Iskoola Pota"/>
+        <a:font script="Mong" typeface="Mongolian Baiti"/>
+        <a:font script="Viet" typeface="Times New Roman"/>
+        <a:font script="Uigh" typeface="Microsoft Uighur"/>
+        <a:font script="Geor" typeface="Sylfaen"/>
+      </a:majorFont>
+      <a:minorFont>
+        <a:latin typeface="Calibri"/>
+        <a:ea typeface=""/>
+        <a:cs typeface=""/>
+        <a:font script="Jpan" typeface="ＭＳ Ｐゴシック"/>
+        <a:font script="Hang" typeface="맑은 고딕"/>
+        <a:font script="Hans" typeface="宋体"/>
+        <a:font script="Hant" typeface="新細明體"/>
+        <a:font script="Arab" typeface="Arial"/>
+        <a:font script="Hebr" typeface="Arial"/>
+        <a:font script="Thai" typeface="Cordia New"/>
+        <a:font script="Ethi" typeface="Nyala"/>
+        <a:font script="Beng" typeface="Vrinda"/>
+        <a:font script="Gujr" typeface="Shruti"/>
+        <a:font script="Khmr" typeface="DaunPenh"/>
+        <a:font script="Knda" typeface="Tunga"/>
+        <a:font script="Guru" typeface="Raavi"/>
+        <a:font script="Cans" typeface="Euphemia"/>
+        <a:font script="Cher" typeface="Plantagenet Cherokee"/>
+        <a:font script="Yiii" typeface="Microsoft Yi Baiti"/>
+        <a:font script="Tibt" typeface="Microsoft Himalaya"/>
+        <a:font script="Thaa" typeface="MV Boli"/>
+        <a:font script="Deva" typeface="Mangal"/>
+        <a:font script="Telu" typeface="Gautami"/>
+        <a:font script="Taml" typeface="Latha"/>
+        <a:font script="Syrc" typeface="Estrangelo Edessa"/>
+        <a:font script="Orya" typeface="Kalinga"/>
+        <a:font script="Mlym" typeface="Kartika"/>
+        <a:font script="Laoo" typeface="DokChampa"/>
+        <a:font script="Sinh" typeface="Iskoola Pota"/>
+        <a:font script="Mong" typeface="Mongolian Baiti"/>
+        <a:font script="Viet" typeface="Arial"/>
+        <a:font script="Uigh" typeface="Microsoft Uighur"/>
+        <a:font script="Geor" typeface="Sylfaen"/>
+      </a:minorFont>
+    </a:fontScheme>
+    <a:fmtScheme name="Office">
+      <a:fillStyleLst>
+        <a:solidFill>
+          <a:schemeClr val="phClr"/>
+        </a:solidFill>
+        <a:gradFill rotWithShape="1">
+          <a:gsLst>
+            <a:gs pos="0">
+              <a:schemeClr val="phClr">
+                <a:tint val="50000"/>
+                <a:satMod val="300000"/>
+              </a:schemeClr>
+            </a:gs>
+            <a:gs pos="35000">
+              <a:schemeClr val="phClr">
+                <a:tint val="37000"/>
+                <a:satMod val="300000"/>
+              </a:schemeClr>
+            </a:gs>
+            <a:gs pos="100000">
+              <a:schemeClr val="phClr">
+                <a:tint val="15000"/>
+                <a:satMod val="350000"/>
+              </a:schemeClr>
+            </a:gs>
+          </a:gsLst>
+          <a:lin ang="16200000" scaled="1"/>
+        </a:gradFill>
+        <a:gradFill rotWithShape="1">
+          <a:gsLst>
+            <a:gs pos="0">
+              <a:schemeClr val="phClr">
+                <a:tint val="100000"/>
+                <a:shade val="100000"/>
+                <a:satMod val="130000"/>
+              </a:schemeClr>
+            </a:gs>
+            <a:gs pos="100000">
+              <a:schemeClr val="phClr">
+                <a:tint val="50000"/>
+                <a:shade val="100000"/>
+                <a:satMod val="350000"/>
+              </a:schemeClr>
+            </a:gs>
+          </a:gsLst>
+          <a:lin ang="16200000" scaled="0"/>
+        </a:gradFill>
+      </a:fillStyleLst>
+      <a:lnStyleLst>
+        <a:ln w="9525" cap="flat" cmpd="sng" algn="ctr">
+          <a:solidFill>
+            <a:schemeClr val="phClr">
+              <a:shade val="95000"/>
+              <a:satMod val="105000"/>
+            </a:schemeClr>
+          </a:solidFill>
+          <a:prstDash val="solid"/>
+        </a:ln>
+        <a:ln w="25400" cap="flat" cmpd="sng" algn="ctr">
+          <a:solidFill>
+            <a:schemeClr val="phClr"/>
+          </a:solidFill>
+          <a:prstDash val="solid"/>
+        </a:ln>
+        <a:ln w="38100" cap="flat" cmpd="sng" algn="ctr">
+          <a:solidFill>
+            <a:schemeClr val="phClr"/>
+          </a:solidFill>
+          <a:prstDash val="solid"/>
+        </a:ln>
+      </a:lnStyleLst>
+      <a:effectStyleLst>
+        <a:effectStyle>
+          <a:effectLst>
+            <a:outerShdw blurRad="40000" dist="20000" dir="5400000" rotWithShape="0">
+              <a:srgbClr val="000000">
+                <a:alpha val="38000"/>
+              </a:srgbClr>
+            </a:outerShdw>
+          </a:effectLst>
+        </a:effectStyle>
+        <a:effectStyle>
+          <a:effectLst>
+            <a:outerShdw blurRad="40000" dist="23000" dir="5400000" rotWithShape="0">
+              <a:srgbClr val="000000">
+                <a:alpha val="35000"/>
+              </a:srgbClr>
+            </a:outerShdw>
+          </a:effectLst>
+        </a:effectStyle>
+        <a:effectStyle>
+          <a:effectLst>
+            <a:outerShdw blurRad="40000" dist="23000" dir="5400000" rotWithShape="0">
+              <a:srgbClr val="000000">
+                <a:alpha val="35000"/>
+              </a:srgbClr>
+            </a:outerShdw>
+          </a:effectLst>
+          <a:scene3d>
+            <a:camera prst="orthographicFront">
+              <a:rot lat="0" lon="0" rev="0"/>
+            </a:camera>
+            <a:lightRig rig="threePt" dir="t">
+              <a:rot lat="0" lon="0" rev="1200000"/>
+            </a:lightRig>
+          </a:scene3d>
+          <a:sp3d>
+            <a:bevelT w="63500" h="25400"/>
+          </a:sp3d>
+        </a:effectStyle>
+      </a:effectStyleLst>
+      <a:bgFillStyleLst>
+        <a:solidFill>
+          <a:schemeClr val="phClr"/>
+        </a:solidFill>
+        <a:gradFill rotWithShape="1">
+          <a:gsLst>
+            <a:gs pos="0">
+              <a:schemeClr val="phClr">
+                <a:tint val="40000"/>
+                <a:satMod val="350000"/>
+              </a:schemeClr>
+            </a:gs>
+            <a:gs pos="40000">
+              <a:schemeClr val="phClr">
+                <a:tint val="45000"/>
+                <a:shade val="99000"/>
+                <a:satMod val="350000"/>
+              </a:schemeClr>
+            </a:gs>
+            <a:gs pos="100000">
+              <a:schemeClr val="phClr">
+                <a:shade val="20000"/>
+                <a:satMod val="255000"/>
+              </a:schemeClr>
+            </a:gs>
+          </a:gsLst>
+          <a:path path="circle">
+            <a:fillToRect l="50000" t="-80000" r="50000" b="180000"/>
+          </a:path>
+        </a:gradFill>
+        <a:gradFill rotWithShape="1">
+          <a:gsLst>
+            <a:gs pos="0">
+              <a:schemeClr val="phClr">
+                <a:tint val="80000"/>
+                <a:satMod val="300000"/>
+              </a:schemeClr>
+            </a:gs>
+            <a:gs pos="100000">
+              <a:schemeClr val="phClr">
+                <a:shade val="30000"/>
+                <a:satMod val="200000"/>
+              </a:schemeClr>
+            </a:gs>
+          </a:gsLst>
+          <a:path path="circle">
+            <a:fillToRect l="50000" t="50000" r="50000" b="50000"/>
+          </a:path>
+        </a:gradFill>
+      </a:bgFillStyleLst>
+    </a:fmtScheme>
+  </a:themeElements>
+  <a:objectDefaults>
+    <a:spDef>
+      <a:spPr/>
+      <a:bodyPr/>
+      <a:lstStyle/>
+      <a:style>
+        <a:lnRef idx="1">
+          <a:schemeClr val="accent1"/>
+        </a:lnRef>
+        <a:fillRef idx="3">
+          <a:schemeClr val="accent1"/>
+        </a:fillRef>
+        <a:effectRef idx="2">
+          <a:schemeClr val="accent1"/>
+        </a:effectRef>
+        <a:fontRef idx="minor">
+          <a:schemeClr val="lt1"/>
+        </a:fontRef>
+      </a:style>
+    </a:spDef>
+    <a:lnDef>
+      <a:spPr/>
+      <a:bodyPr/>
+      <a:lstStyle/>
+      <a:style>
+        <a:lnRef idx="2">
+          <a:schemeClr val="accent1"/>
+        </a:lnRef>
+        <a:fillRef idx="0">
+          <a:schemeClr val="accent1"/>
+        </a:fillRef>
+        <a:effectRef idx="1">
+          <a:schemeClr val="accent1"/>
+        </a:effectRef>
+        <a:fontRef idx="minor">
+          <a:schemeClr val="tx1"/>
+        </a:fontRef>
+      </a:style>
+    </a:lnDef>
+  </a:objectDefaults>
+  <a:extraClrSchemeLst/>
+</a:theme>
 </file>
</xml_diff>